<commit_message>
Use latest uploaded Intro slides
</commit_message>
<xml_diff>
--- a/folien/Intro.pptx
+++ b/folien/Intro.pptx
@@ -1,28 +1,123 @@
 
 <file path=ppt/presentation.xml><?xml version="1.0" encoding="utf-8"?>
-<p:presentation xmlns:p="http://schemas.openxmlformats.org/presentationml/2006/main">
+<p:presentation xmlns:a="http://schemas.openxmlformats.org/drawingml/2006/main" xmlns:r="http://schemas.openxmlformats.org/officeDocument/2006/relationships" xmlns:p="http://schemas.openxmlformats.org/presentationml/2006/main">
   <p:sldMasterIdLst>
-    <p:sldMasterId xmlns:r="http://schemas.openxmlformats.org/officeDocument/2006/relationships" id="2147483648" r:id="Ra29a90c2158d4d61"/>
+    <p:sldMasterId id="2147483648" r:id="rId1"/>
   </p:sldMasterIdLst>
   <p:notesMasterIdLst>
-    <p:notesMasterId xmlns:r="http://schemas.openxmlformats.org/officeDocument/2006/relationships" r:id="R844de50981b44b39"/>
+    <p:notesMasterId r:id="rId5"/>
   </p:notesMasterIdLst>
   <p:sldIdLst>
-    <p:sldId xmlns:r="http://schemas.openxmlformats.org/officeDocument/2006/relationships" id="256" r:id="R673b96c1b85c4c66"/>
-    <p:sldId xmlns:r="http://schemas.openxmlformats.org/officeDocument/2006/relationships" id="257" r:id="R3619768be18b4966"/>
-    <p:sldId xmlns:r="http://schemas.openxmlformats.org/officeDocument/2006/relationships" id="258" r:id="R28643a5b03a9473a"/>
+    <p:sldId id="256" r:id="rId2"/>
+    <p:sldId id="257" r:id="rId3"/>
+    <p:sldId id="258" r:id="rId4"/>
   </p:sldIdLst>
   <p:sldSz cx="12192000" cy="6858000"/>
   <p:notesSz cx="6858000" cy="9144000"/>
+  <p:defaultTextStyle>
+    <a:defPPr>
+      <a:defRPr lang="en-DE"/>
+    </a:defPPr>
+    <a:lvl1pPr marL="0" algn="l" defTabSz="914400" rtl="0" eaLnBrk="1" latinLnBrk="0" hangingPunct="1">
+      <a:defRPr sz="1800" kern="1200">
+        <a:solidFill>
+          <a:schemeClr val="tx1"/>
+        </a:solidFill>
+        <a:latin typeface="+mn-lt"/>
+        <a:ea typeface="+mn-ea"/>
+        <a:cs typeface="+mn-cs"/>
+      </a:defRPr>
+    </a:lvl1pPr>
+    <a:lvl2pPr marL="457200" algn="l" defTabSz="914400" rtl="0" eaLnBrk="1" latinLnBrk="0" hangingPunct="1">
+      <a:defRPr sz="1800" kern="1200">
+        <a:solidFill>
+          <a:schemeClr val="tx1"/>
+        </a:solidFill>
+        <a:latin typeface="+mn-lt"/>
+        <a:ea typeface="+mn-ea"/>
+        <a:cs typeface="+mn-cs"/>
+      </a:defRPr>
+    </a:lvl2pPr>
+    <a:lvl3pPr marL="914400" algn="l" defTabSz="914400" rtl="0" eaLnBrk="1" latinLnBrk="0" hangingPunct="1">
+      <a:defRPr sz="1800" kern="1200">
+        <a:solidFill>
+          <a:schemeClr val="tx1"/>
+        </a:solidFill>
+        <a:latin typeface="+mn-lt"/>
+        <a:ea typeface="+mn-ea"/>
+        <a:cs typeface="+mn-cs"/>
+      </a:defRPr>
+    </a:lvl3pPr>
+    <a:lvl4pPr marL="1371600" algn="l" defTabSz="914400" rtl="0" eaLnBrk="1" latinLnBrk="0" hangingPunct="1">
+      <a:defRPr sz="1800" kern="1200">
+        <a:solidFill>
+          <a:schemeClr val="tx1"/>
+        </a:solidFill>
+        <a:latin typeface="+mn-lt"/>
+        <a:ea typeface="+mn-ea"/>
+        <a:cs typeface="+mn-cs"/>
+      </a:defRPr>
+    </a:lvl4pPr>
+    <a:lvl5pPr marL="1828800" algn="l" defTabSz="914400" rtl="0" eaLnBrk="1" latinLnBrk="0" hangingPunct="1">
+      <a:defRPr sz="1800" kern="1200">
+        <a:solidFill>
+          <a:schemeClr val="tx1"/>
+        </a:solidFill>
+        <a:latin typeface="+mn-lt"/>
+        <a:ea typeface="+mn-ea"/>
+        <a:cs typeface="+mn-cs"/>
+      </a:defRPr>
+    </a:lvl5pPr>
+    <a:lvl6pPr marL="2286000" algn="l" defTabSz="914400" rtl="0" eaLnBrk="1" latinLnBrk="0" hangingPunct="1">
+      <a:defRPr sz="1800" kern="1200">
+        <a:solidFill>
+          <a:schemeClr val="tx1"/>
+        </a:solidFill>
+        <a:latin typeface="+mn-lt"/>
+        <a:ea typeface="+mn-ea"/>
+        <a:cs typeface="+mn-cs"/>
+      </a:defRPr>
+    </a:lvl6pPr>
+    <a:lvl7pPr marL="2743200" algn="l" defTabSz="914400" rtl="0" eaLnBrk="1" latinLnBrk="0" hangingPunct="1">
+      <a:defRPr sz="1800" kern="1200">
+        <a:solidFill>
+          <a:schemeClr val="tx1"/>
+        </a:solidFill>
+        <a:latin typeface="+mn-lt"/>
+        <a:ea typeface="+mn-ea"/>
+        <a:cs typeface="+mn-cs"/>
+      </a:defRPr>
+    </a:lvl7pPr>
+    <a:lvl8pPr marL="3200400" algn="l" defTabSz="914400" rtl="0" eaLnBrk="1" latinLnBrk="0" hangingPunct="1">
+      <a:defRPr sz="1800" kern="1200">
+        <a:solidFill>
+          <a:schemeClr val="tx1"/>
+        </a:solidFill>
+        <a:latin typeface="+mn-lt"/>
+        <a:ea typeface="+mn-ea"/>
+        <a:cs typeface="+mn-cs"/>
+      </a:defRPr>
+    </a:lvl8pPr>
+    <a:lvl9pPr marL="3657600" algn="l" defTabSz="914400" rtl="0" eaLnBrk="1" latinLnBrk="0" hangingPunct="1">
+      <a:defRPr sz="1800" kern="1200">
+        <a:solidFill>
+          <a:schemeClr val="tx1"/>
+        </a:solidFill>
+        <a:latin typeface="+mn-lt"/>
+        <a:ea typeface="+mn-ea"/>
+        <a:cs typeface="+mn-cs"/>
+      </a:defRPr>
+    </a:lvl9pPr>
+  </p:defaultTextStyle>
 </p:presentation>
 </file>
 
 <file path=ppt/notesMasters/notesMaster1.xml><?xml version="1.0" encoding="utf-8"?>
-<p:notesMaster xmlns:p="http://schemas.openxmlformats.org/presentationml/2006/main">
+<p:notesMaster xmlns:a="http://schemas.openxmlformats.org/drawingml/2006/main" xmlns:r="http://schemas.openxmlformats.org/officeDocument/2006/relationships" xmlns:p="http://schemas.openxmlformats.org/presentationml/2006/main">
   <p:cSld>
     <p:bg>
       <p:bgRef idx="1001">
-        <a:schemeClr xmlns:a="http://schemas.openxmlformats.org/drawingml/2006/main" val="bg1"/>
+        <a:schemeClr val="bg1"/>
       </p:bgRef>
     </p:bg>
     <p:spTree>
@@ -32,380 +127,164 @@
         <p:nvPr/>
       </p:nvGrpSpPr>
       <p:grpSpPr>
-        <a:xfrm xmlns:a="http://schemas.openxmlformats.org/drawingml/2006/main"/>
+        <a:xfrm>
+          <a:off x="0" y="0"/>
+          <a:ext cx="0" cy="0"/>
+          <a:chOff x="0" y="0"/>
+          <a:chExt cx="0" cy="0"/>
+        </a:xfrm>
       </p:grpSpPr>
       <p:sp>
         <p:nvSpPr>
           <p:cNvPr id="2" name="Header Placeholder"/>
-          <p:cNvSpPr/>
+          <p:cNvSpPr>
+            <a:spLocks noGrp="1"/>
+          </p:cNvSpPr>
           <p:nvPr>
             <p:ph type="hdr" sz="quarter"/>
           </p:nvPr>
         </p:nvSpPr>
         <p:spPr>
-          <a:prstGeom xmlns:a="http://schemas.openxmlformats.org/drawingml/2006/main" prst="rect">
+          <a:prstGeom prst="rect">
             <a:avLst/>
           </a:prstGeom>
         </p:spPr>
         <p:txBody>
-          <a:bodyPr xmlns:a="http://schemas.openxmlformats.org/drawingml/2006/main"/>
-          <a:lstStyle xmlns:a="http://schemas.openxmlformats.org/drawingml/2006/main"/>
-          <a:p xmlns:a="http://schemas.openxmlformats.org/drawingml/2006/main"/>
+          <a:bodyPr/>
+          <a:lstStyle/>
+          <a:p>
+            <a:endParaRPr/>
+          </a:p>
         </p:txBody>
       </p:sp>
       <p:sp>
         <p:nvSpPr>
           <p:cNvPr id="3" name="Date Placeholder"/>
-          <p:cNvSpPr/>
+          <p:cNvSpPr>
+            <a:spLocks noGrp="1"/>
+          </p:cNvSpPr>
           <p:nvPr>
             <p:ph type="dt" sz="quarter" idx="1"/>
           </p:nvPr>
         </p:nvSpPr>
         <p:spPr>
-          <a:prstGeom xmlns:a="http://schemas.openxmlformats.org/drawingml/2006/main" prst="rect">
+          <a:prstGeom prst="rect">
             <a:avLst/>
           </a:prstGeom>
         </p:spPr>
         <p:txBody>
-          <a:bodyPr xmlns:a="http://schemas.openxmlformats.org/drawingml/2006/main"/>
-          <a:lstStyle xmlns:a="http://schemas.openxmlformats.org/drawingml/2006/main"/>
-          <a:p xmlns:a="http://schemas.openxmlformats.org/drawingml/2006/main"/>
+          <a:bodyPr/>
+          <a:lstStyle/>
+          <a:p>
+            <a:endParaRPr/>
+          </a:p>
         </p:txBody>
       </p:sp>
       <p:sp>
         <p:nvSpPr>
           <p:cNvPr id="4" name="Slide Image Placeholder"/>
-          <p:cNvSpPr/>
+          <p:cNvSpPr>
+            <a:spLocks noGrp="1" noRot="1" noChangeAspect="1"/>
+          </p:cNvSpPr>
           <p:nvPr>
             <p:ph type="sldImg" idx="2"/>
           </p:nvPr>
         </p:nvSpPr>
         <p:spPr>
-          <a:prstGeom xmlns:a="http://schemas.openxmlformats.org/drawingml/2006/main" prst="rect">
+          <a:prstGeom prst="rect">
             <a:avLst/>
           </a:prstGeom>
         </p:spPr>
         <p:txBody>
-          <a:bodyPr xmlns:a="http://schemas.openxmlformats.org/drawingml/2006/main"/>
-          <a:lstStyle xmlns:a="http://schemas.openxmlformats.org/drawingml/2006/main"/>
-          <a:p xmlns:a="http://schemas.openxmlformats.org/drawingml/2006/main"/>
+          <a:bodyPr/>
+          <a:lstStyle/>
+          <a:p>
+            <a:endParaRPr/>
+          </a:p>
         </p:txBody>
       </p:sp>
       <p:sp>
         <p:nvSpPr>
           <p:cNvPr id="5" name="Notes Placeholder"/>
-          <p:cNvSpPr/>
+          <p:cNvSpPr>
+            <a:spLocks noGrp="1"/>
+          </p:cNvSpPr>
           <p:nvPr>
             <p:ph type="body" sz="quarter" idx="3"/>
           </p:nvPr>
         </p:nvSpPr>
         <p:spPr>
-          <a:prstGeom xmlns:a="http://schemas.openxmlformats.org/drawingml/2006/main" prst="rect">
+          <a:prstGeom prst="rect">
             <a:avLst/>
           </a:prstGeom>
         </p:spPr>
         <p:txBody>
-          <a:bodyPr xmlns:a="http://schemas.openxmlformats.org/drawingml/2006/main"/>
-          <a:lstStyle xmlns:a="http://schemas.openxmlformats.org/drawingml/2006/main"/>
-          <a:p xmlns:a="http://schemas.openxmlformats.org/drawingml/2006/main"/>
+          <a:bodyPr/>
+          <a:lstStyle/>
+          <a:p>
+            <a:endParaRPr/>
+          </a:p>
         </p:txBody>
       </p:sp>
       <p:sp>
         <p:nvSpPr>
           <p:cNvPr id="6" name="Footer Placeholder"/>
-          <p:cNvSpPr/>
+          <p:cNvSpPr>
+            <a:spLocks noGrp="1"/>
+          </p:cNvSpPr>
           <p:nvPr>
             <p:ph type="ftr" sz="quarter" idx="4"/>
           </p:nvPr>
         </p:nvSpPr>
         <p:spPr>
-          <a:prstGeom xmlns:a="http://schemas.openxmlformats.org/drawingml/2006/main" prst="rect">
+          <a:prstGeom prst="rect">
             <a:avLst/>
           </a:prstGeom>
         </p:spPr>
         <p:txBody>
-          <a:bodyPr xmlns:a="http://schemas.openxmlformats.org/drawingml/2006/main"/>
-          <a:lstStyle xmlns:a="http://schemas.openxmlformats.org/drawingml/2006/main"/>
-          <a:p xmlns:a="http://schemas.openxmlformats.org/drawingml/2006/main"/>
+          <a:bodyPr/>
+          <a:lstStyle/>
+          <a:p>
+            <a:endParaRPr/>
+          </a:p>
         </p:txBody>
       </p:sp>
       <p:sp>
         <p:nvSpPr>
           <p:cNvPr id="7" name="Slide Number Placeholder"/>
-          <p:cNvSpPr/>
+          <p:cNvSpPr>
+            <a:spLocks noGrp="1"/>
+          </p:cNvSpPr>
           <p:nvPr>
             <p:ph type="sldNum" sz="quarter" idx="5"/>
           </p:nvPr>
         </p:nvSpPr>
         <p:spPr>
-          <a:prstGeom xmlns:a="http://schemas.openxmlformats.org/drawingml/2006/main" prst="rect">
+          <a:prstGeom prst="rect">
             <a:avLst/>
           </a:prstGeom>
         </p:spPr>
         <p:txBody>
-          <a:bodyPr xmlns:a="http://schemas.openxmlformats.org/drawingml/2006/main"/>
-          <a:lstStyle xmlns:a="http://schemas.openxmlformats.org/drawingml/2006/main"/>
-          <a:p xmlns:a="http://schemas.openxmlformats.org/drawingml/2006/main"/>
+          <a:bodyPr/>
+          <a:lstStyle/>
+          <a:p>
+            <a:endParaRPr/>
+          </a:p>
         </p:txBody>
       </p:sp>
     </p:spTree>
   </p:cSld>
   <p:clrMap bg1="lt1" tx1="dk1" bg2="lt2" tx2="dk2" accent1="accent1" accent2="accent2" accent3="accent3" accent4="accent4" accent5="accent5" accent6="accent6" hlink="hlink" folHlink="folHlink"/>
   <p:notesStyle>
-    <a:lvl1pPr xmlns:a="http://schemas.openxmlformats.org/drawingml/2006/main" marL="0" algn="l" defTabSz="914400" rtl="0" eaLnBrk="1" latinLnBrk="0" hangingPunct="1">
+    <a:lvl1pPr marL="0" algn="l" defTabSz="914400" rtl="0" eaLnBrk="1" latinLnBrk="0" hangingPunct="1">
       <a:defRPr sz="1200" kern="1200"/>
     </a:lvl1pPr>
   </p:notesStyle>
 </p:notesMaster>
 </file>
 
-<file path=ppt/notesMasters/theme/theme3.xml><?xml version="1.0" encoding="utf-8"?>
-<a:theme xmlns:a="http://schemas.openxmlformats.org/drawingml/2006/main" name="ChatGPT">
-  <a:themeElements>
-    <a:clrScheme name="ChatGPT">
-      <a:dk1>
-        <a:srgbClr val="000000"/>
-      </a:dk1>
-      <a:lt1>
-        <a:srgbClr val="FFFFFF"/>
-      </a:lt1>
-      <a:dk2>
-        <a:srgbClr val="0E2841"/>
-      </a:dk2>
-      <a:lt2>
-        <a:srgbClr val="E8E8E8"/>
-      </a:lt2>
-      <a:accent1>
-        <a:srgbClr val="156082"/>
-      </a:accent1>
-      <a:accent2>
-        <a:srgbClr val="E97132"/>
-      </a:accent2>
-      <a:accent3>
-        <a:srgbClr val="196B24"/>
-      </a:accent3>
-      <a:accent4>
-        <a:srgbClr val="0F9ED5"/>
-      </a:accent4>
-      <a:accent5>
-        <a:srgbClr val="A02B93"/>
-      </a:accent5>
-      <a:accent6>
-        <a:srgbClr val="4EA72E"/>
-      </a:accent6>
-      <a:hlink>
-        <a:srgbClr val="467886"/>
-      </a:hlink>
-      <a:folHlink>
-        <a:srgbClr val="96607D"/>
-      </a:folHlink>
-    </a:clrScheme>
-    <a:fontScheme name="">
-      <a:majorFont>
-        <a:latin typeface="Aptos"/>
-        <a:ea typeface=""/>
-        <a:cs typeface=""/>
-      </a:majorFont>
-      <a:minorFont>
-        <a:latin typeface="Aptos"/>
-        <a:ea typeface=""/>
-        <a:cs typeface=""/>
-      </a:minorFont>
-    </a:fontScheme>
-    <a:fmtScheme name="ChatGPT">
-      <a:fillStyleLst>
-        <a:solidFill>
-          <a:schemeClr val="phClr"/>
-        </a:solidFill>
-        <a:gradFill>
-          <a:gsLst>
-            <a:gs pos="0">
-              <a:schemeClr val="phClr">
-                <a:tint val="67000"/>
-                <a:lumMod val="110000"/>
-                <a:satMod val="105000"/>
-              </a:schemeClr>
-            </a:gs>
-            <a:gs pos="50000">
-              <a:schemeClr val="phClr">
-                <a:tint val="73000"/>
-                <a:lumMod val="105000"/>
-                <a:satMod val="103000"/>
-              </a:schemeClr>
-            </a:gs>
-            <a:gs pos="100000">
-              <a:schemeClr val="phClr">
-                <a:tint val="81000"/>
-                <a:lumMod val="105000"/>
-                <a:satMod val="109000"/>
-              </a:schemeClr>
-            </a:gs>
-          </a:gsLst>
-          <a:lin ang="5400000" scaled="0"/>
-        </a:gradFill>
-        <a:gradFill>
-          <a:gsLst>
-            <a:gs pos="0">
-              <a:schemeClr val="phClr">
-                <a:tint val="94000"/>
-                <a:lumMod val="102000"/>
-                <a:satMod val="103000"/>
-              </a:schemeClr>
-            </a:gs>
-            <a:gs pos="50000">
-              <a:schemeClr val="phClr">
-                <a:shade val="100000"/>
-                <a:lumMod val="100000"/>
-                <a:satMod val="110000"/>
-              </a:schemeClr>
-            </a:gs>
-            <a:gs pos="100000">
-              <a:schemeClr val="phClr">
-                <a:shade val="78000"/>
-                <a:lumMod val="99000"/>
-                <a:satMod val="120000"/>
-              </a:schemeClr>
-            </a:gs>
-          </a:gsLst>
-          <a:lin ang="5400000" scaled="0"/>
-        </a:gradFill>
-      </a:fillStyleLst>
-      <a:lnStyleLst>
-        <a:ln w="12700">
-          <a:solidFill>
-            <a:schemeClr val="phClr"/>
-          </a:solidFill>
-          <a:prstDash val="solid"/>
-        </a:ln>
-        <a:ln w="19050">
-          <a:solidFill>
-            <a:schemeClr val="phClr"/>
-          </a:solidFill>
-          <a:prstDash val="solid"/>
-        </a:ln>
-        <a:ln w="25400">
-          <a:solidFill>
-            <a:schemeClr val="phClr"/>
-          </a:solidFill>
-          <a:prstDash val="solid"/>
-        </a:ln>
-      </a:lnStyleLst>
-      <a:effectStyleLst>
-        <a:effectStyle>
-          <a:effectLst/>
-        </a:effectStyle>
-        <a:effectStyle>
-          <a:effectLst/>
-        </a:effectStyle>
-        <a:effectStyle>
-          <a:effectLst>
-            <a:outerShdw blurRad="57150" dist="19050" dir="5400000">
-              <a:srgbClr val="000000">
-                <a:alpha val="16000"/>
-              </a:srgbClr>
-            </a:outerShdw>
-          </a:effectLst>
-        </a:effectStyle>
-        <a:effectStyle>
-          <a:effectLst>
-            <a:outerShdw blurRad="19050" dist="9525" dir="5400000">
-              <a:srgbClr val="000000">
-                <a:alpha val="6000"/>
-              </a:srgbClr>
-            </a:outerShdw>
-          </a:effectLst>
-        </a:effectStyle>
-        <a:effectStyle>
-          <a:effectLst>
-            <a:outerShdw blurRad="28575" dist="9525" dir="5400000">
-              <a:srgbClr val="000000">
-                <a:alpha val="8000"/>
-              </a:srgbClr>
-            </a:outerShdw>
-          </a:effectLst>
-        </a:effectStyle>
-        <a:effectStyle>
-          <a:effectLst>
-            <a:outerShdw blurRad="57150" dist="19050" dir="5400000">
-              <a:srgbClr val="000000">
-                <a:alpha val="10000"/>
-              </a:srgbClr>
-            </a:outerShdw>
-          </a:effectLst>
-        </a:effectStyle>
-        <a:effectStyle>
-          <a:effectLst>
-            <a:outerShdw blurRad="114300" dist="38100" dir="5400000">
-              <a:srgbClr val="000000">
-                <a:alpha val="12000"/>
-              </a:srgbClr>
-            </a:outerShdw>
-          </a:effectLst>
-        </a:effectStyle>
-        <a:effectStyle>
-          <a:effectLst>
-            <a:outerShdw blurRad="171450" dist="57150" dir="5400000">
-              <a:srgbClr val="000000">
-                <a:alpha val="16000"/>
-              </a:srgbClr>
-            </a:outerShdw>
-          </a:effectLst>
-        </a:effectStyle>
-        <a:effectStyle>
-          <a:effectLst>
-            <a:outerShdw blurRad="266700" dist="95250" dir="5400000">
-              <a:srgbClr val="000000">
-                <a:alpha val="24000"/>
-              </a:srgbClr>
-            </a:outerShdw>
-          </a:effectLst>
-        </a:effectStyle>
-      </a:effectStyleLst>
-      <a:bgFillStyleLst>
-        <a:solidFill>
-          <a:schemeClr val="phClr"/>
-        </a:solidFill>
-        <a:solidFill>
-          <a:schemeClr val="phClr">
-            <a:tint val="95000"/>
-            <a:satMod val="170000"/>
-          </a:schemeClr>
-        </a:solidFill>
-        <a:gradFill>
-          <a:gsLst>
-            <a:gs pos="0">
-              <a:schemeClr val="phClr">
-                <a:tint val="93000"/>
-                <a:shade val="98000"/>
-                <a:lumMod val="102000"/>
-                <a:satMod val="150000"/>
-              </a:schemeClr>
-            </a:gs>
-            <a:gs pos="50000">
-              <a:schemeClr val="phClr">
-                <a:tint val="98000"/>
-                <a:shade val="90000"/>
-                <a:lumMod val="103000"/>
-                <a:satMod val="130000"/>
-              </a:schemeClr>
-            </a:gs>
-            <a:gs pos="100000">
-              <a:schemeClr val="phClr">
-                <a:shade val="63000"/>
-                <a:satMod val="120000"/>
-              </a:schemeClr>
-            </a:gs>
-          </a:gsLst>
-          <a:lin ang="5400000" scaled="0"/>
-        </a:gradFill>
-      </a:bgFillStyleLst>
-    </a:fmtScheme>
-  </a:themeElements>
-</a:theme>
-</file>
-
 <file path=ppt/notesSlides/notesSlide1.xml><?xml version="1.0" encoding="utf-8"?>
-<p:notes xmlns:p="http://schemas.openxmlformats.org/presentationml/2006/main">
+<p:notes xmlns:a="http://schemas.openxmlformats.org/drawingml/2006/main" xmlns:r="http://schemas.openxmlformats.org/officeDocument/2006/relationships" xmlns:p="http://schemas.openxmlformats.org/presentationml/2006/main">
   <p:cSld>
     <p:spTree>
       <p:nvGrpSpPr>
@@ -414,16 +293,21 @@
         <p:nvPr/>
       </p:nvGrpSpPr>
       <p:grpSpPr>
-        <a:xfrm xmlns:a="http://schemas.openxmlformats.org/drawingml/2006/main"/>
+        <a:xfrm>
+          <a:off x="0" y="0"/>
+          <a:ext cx="0" cy="0"/>
+          <a:chOff x="0" y="0"/>
+          <a:chExt cx="0" cy="0"/>
+        </a:xfrm>
       </p:grpSpPr>
       <p:sp>
         <p:nvSpPr>
           <p:cNvPr id="2" name="Slide Image Placeholder 1"/>
           <p:cNvSpPr>
-            <a:spLocks xmlns:a="http://schemas.openxmlformats.org/drawingml/2006/main" noGrp="1"/>
+            <a:spLocks noGrp="1" noRot="1" noChangeAspect="1"/>
           </p:cNvSpPr>
           <p:nvPr>
-            <p:ph type="sldImg" idx="0"/>
+            <p:ph type="sldImg"/>
           </p:nvPr>
         </p:nvSpPr>
         <p:spPr/>
@@ -432,7 +316,7 @@
         <p:nvSpPr>
           <p:cNvPr id="3" name="Notes Placeholder 2"/>
           <p:cNvSpPr>
-            <a:spLocks xmlns:a="http://schemas.openxmlformats.org/drawingml/2006/main" noGrp="1"/>
+            <a:spLocks noGrp="1"/>
           </p:cNvSpPr>
           <p:nvPr>
             <p:ph type="body" idx="1"/>
@@ -440,9 +324,9 @@
         </p:nvSpPr>
         <p:spPr/>
         <p:txBody>
-          <a:bodyPr xmlns:a="http://schemas.openxmlformats.org/drawingml/2006/main"/>
-          <a:lstStyle xmlns:a="http://schemas.openxmlformats.org/drawingml/2006/main"/>
-          <a:p xmlns:a="http://schemas.openxmlformats.org/drawingml/2006/main">
+          <a:bodyPr/>
+          <a:lstStyle/>
+          <a:p>
             <a:r>
               <a:t>Tutorialtermine und Räume: Screenshot 2026-10-19 at 13.11.33.png, bereitgestellt vom Nutzer. Der Screenshot zeigt Startzeiten, keine verbindlichen Endzeiten. Repository: https://github.com/IlyaKats2005/GDB_2026-2027_Tutorium. Diese Titelfolie für jede Woche verwenden: Intro durch Woche 1, Woche 2 usw. ersetzen. Name, Termine, Semester und QR-Code beibehalten.</a:t>
             </a:r>
@@ -453,7 +337,7 @@
         <p:nvSpPr>
           <p:cNvPr id="4" name="Slide Number Placeholder 3"/>
           <p:cNvSpPr>
-            <a:spLocks xmlns:a="http://schemas.openxmlformats.org/drawingml/2006/main" noGrp="1"/>
+            <a:spLocks noGrp="1"/>
           </p:cNvSpPr>
           <p:nvPr>
             <p:ph type="sldNum" idx="5"/>
@@ -461,21 +345,23 @@
         </p:nvSpPr>
         <p:spPr/>
         <p:txBody>
-          <a:bodyPr xmlns:a="http://schemas.openxmlformats.org/drawingml/2006/main"/>
-          <a:lstStyle xmlns:a="http://schemas.openxmlformats.org/drawingml/2006/main"/>
-          <a:p xmlns:a="http://schemas.openxmlformats.org/drawingml/2006/main"/>
+          <a:bodyPr/>
+          <a:lstStyle/>
+          <a:p>
+            <a:endParaRPr/>
+          </a:p>
         </p:txBody>
       </p:sp>
     </p:spTree>
   </p:cSld>
   <p:clrMapOvr>
-    <a:masterClrMapping xmlns:a="http://schemas.openxmlformats.org/drawingml/2006/main"/>
+    <a:masterClrMapping/>
   </p:clrMapOvr>
 </p:notes>
 </file>
 
 <file path=ppt/notesSlides/notesSlide2.xml><?xml version="1.0" encoding="utf-8"?>
-<p:notes xmlns:p="http://schemas.openxmlformats.org/presentationml/2006/main">
+<p:notes xmlns:a="http://schemas.openxmlformats.org/drawingml/2006/main" xmlns:r="http://schemas.openxmlformats.org/officeDocument/2006/relationships" xmlns:p="http://schemas.openxmlformats.org/presentationml/2006/main">
   <p:cSld>
     <p:spTree>
       <p:nvGrpSpPr>
@@ -484,16 +370,21 @@
         <p:nvPr/>
       </p:nvGrpSpPr>
       <p:grpSpPr>
-        <a:xfrm xmlns:a="http://schemas.openxmlformats.org/drawingml/2006/main"/>
+        <a:xfrm>
+          <a:off x="0" y="0"/>
+          <a:ext cx="0" cy="0"/>
+          <a:chOff x="0" y="0"/>
+          <a:chExt cx="0" cy="0"/>
+        </a:xfrm>
       </p:grpSpPr>
       <p:sp>
         <p:nvSpPr>
           <p:cNvPr id="2" name="Slide Image Placeholder 1"/>
           <p:cNvSpPr>
-            <a:spLocks xmlns:a="http://schemas.openxmlformats.org/drawingml/2006/main" noGrp="1"/>
+            <a:spLocks noGrp="1" noRot="1" noChangeAspect="1"/>
           </p:cNvSpPr>
           <p:nvPr>
-            <p:ph type="sldImg" idx="0"/>
+            <p:ph type="sldImg"/>
           </p:nvPr>
         </p:nvSpPr>
         <p:spPr/>
@@ -502,7 +393,7 @@
         <p:nvSpPr>
           <p:cNvPr id="3" name="Notes Placeholder 2"/>
           <p:cNvSpPr>
-            <a:spLocks xmlns:a="http://schemas.openxmlformats.org/drawingml/2006/main" noGrp="1"/>
+            <a:spLocks noGrp="1"/>
           </p:cNvSpPr>
           <p:nvPr>
             <p:ph type="body" idx="1"/>
@@ -510,9 +401,9 @@
         </p:nvSpPr>
         <p:spPr/>
         <p:txBody>
-          <a:bodyPr xmlns:a="http://schemas.openxmlformats.org/drawingml/2006/main"/>
-          <a:lstStyle xmlns:a="http://schemas.openxmlformats.org/drawingml/2006/main"/>
-          <a:p xmlns:a="http://schemas.openxmlformats.org/drawingml/2006/main">
+          <a:bodyPr/>
+          <a:lstStyle/>
+          <a:p>
             <a:r>
               <a:t>Quelle: vom Nutzer bereitgestellter Screenshot 2026-10-19 at 12.37.30.png, Das Bonussystem und Punktevergabe in der Übung. Die Definition aktiver Teilnahme liegt im Ermessen des Tutors. Punkte für Vorrechnen können nach Ermessen auch für Teilaufgaben vergeben werden. Keine Aussage zur Gültigkeit in einer Wiederholungsklausur, da dies im Material nicht geregelt ist.</a:t>
             </a:r>
@@ -523,7 +414,7 @@
         <p:nvSpPr>
           <p:cNvPr id="4" name="Slide Number Placeholder 3"/>
           <p:cNvSpPr>
-            <a:spLocks xmlns:a="http://schemas.openxmlformats.org/drawingml/2006/main" noGrp="1"/>
+            <a:spLocks noGrp="1"/>
           </p:cNvSpPr>
           <p:nvPr>
             <p:ph type="sldNum" idx="5"/>
@@ -531,21 +422,23 @@
         </p:nvSpPr>
         <p:spPr/>
         <p:txBody>
-          <a:bodyPr xmlns:a="http://schemas.openxmlformats.org/drawingml/2006/main"/>
-          <a:lstStyle xmlns:a="http://schemas.openxmlformats.org/drawingml/2006/main"/>
-          <a:p xmlns:a="http://schemas.openxmlformats.org/drawingml/2006/main"/>
+          <a:bodyPr/>
+          <a:lstStyle/>
+          <a:p>
+            <a:endParaRPr/>
+          </a:p>
         </p:txBody>
       </p:sp>
     </p:spTree>
   </p:cSld>
   <p:clrMapOvr>
-    <a:masterClrMapping xmlns:a="http://schemas.openxmlformats.org/drawingml/2006/main"/>
+    <a:masterClrMapping/>
   </p:clrMapOvr>
 </p:notes>
 </file>
 
 <file path=ppt/notesSlides/notesSlide3.xml><?xml version="1.0" encoding="utf-8"?>
-<p:notes xmlns:p="http://schemas.openxmlformats.org/presentationml/2006/main">
+<p:notes xmlns:a="http://schemas.openxmlformats.org/drawingml/2006/main" xmlns:r="http://schemas.openxmlformats.org/officeDocument/2006/relationships" xmlns:p="http://schemas.openxmlformats.org/presentationml/2006/main">
   <p:cSld>
     <p:spTree>
       <p:nvGrpSpPr>
@@ -554,16 +447,21 @@
         <p:nvPr/>
       </p:nvGrpSpPr>
       <p:grpSpPr>
-        <a:xfrm xmlns:a="http://schemas.openxmlformats.org/drawingml/2006/main"/>
+        <a:xfrm>
+          <a:off x="0" y="0"/>
+          <a:ext cx="0" cy="0"/>
+          <a:chOff x="0" y="0"/>
+          <a:chExt cx="0" cy="0"/>
+        </a:xfrm>
       </p:grpSpPr>
       <p:sp>
         <p:nvSpPr>
           <p:cNvPr id="2" name="Slide Image Placeholder 1"/>
           <p:cNvSpPr>
-            <a:spLocks xmlns:a="http://schemas.openxmlformats.org/drawingml/2006/main" noGrp="1"/>
+            <a:spLocks noGrp="1" noRot="1" noChangeAspect="1"/>
           </p:cNvSpPr>
           <p:nvPr>
-            <p:ph type="sldImg" idx="0"/>
+            <p:ph type="sldImg"/>
           </p:nvPr>
         </p:nvSpPr>
         <p:spPr/>
@@ -572,7 +470,7 @@
         <p:nvSpPr>
           <p:cNvPr id="3" name="Notes Placeholder 2"/>
           <p:cNvSpPr>
-            <a:spLocks xmlns:a="http://schemas.openxmlformats.org/drawingml/2006/main" noGrp="1"/>
+            <a:spLocks noGrp="1"/>
           </p:cNvSpPr>
           <p:nvPr>
             <p:ph type="body" idx="1"/>
@@ -580,9 +478,9 @@
         </p:nvSpPr>
         <p:spPr/>
         <p:txBody>
-          <a:bodyPr xmlns:a="http://schemas.openxmlformats.org/drawingml/2006/main"/>
-          <a:lstStyle xmlns:a="http://schemas.openxmlformats.org/drawingml/2006/main"/>
-          <a:p xmlns:a="http://schemas.openxmlformats.org/drawingml/2006/main">
+          <a:bodyPr/>
+          <a:lstStyle/>
+          <a:p>
             <a:r>
               <a:t>Quelle für Buchtitel und Autoren: vom Nutzer bereitgestellter Screenshot 2026-10-19 at 12.37.56.png. Kauf oder Ausleihe ist eine Empfehlung des Tutors. Keine Aussage zur aktuellen Verfügbarkeit oder zu einer verpflichtenden Anschaffung.</a:t>
             </a:r>
@@ -593,7 +491,7 @@
         <p:nvSpPr>
           <p:cNvPr id="4" name="Slide Number Placeholder 3"/>
           <p:cNvSpPr>
-            <a:spLocks xmlns:a="http://schemas.openxmlformats.org/drawingml/2006/main" noGrp="1"/>
+            <a:spLocks noGrp="1"/>
           </p:cNvSpPr>
           <p:nvPr>
             <p:ph type="sldNum" idx="5"/>
@@ -601,21 +499,23 @@
         </p:nvSpPr>
         <p:spPr/>
         <p:txBody>
-          <a:bodyPr xmlns:a="http://schemas.openxmlformats.org/drawingml/2006/main"/>
-          <a:lstStyle xmlns:a="http://schemas.openxmlformats.org/drawingml/2006/main"/>
-          <a:p xmlns:a="http://schemas.openxmlformats.org/drawingml/2006/main"/>
+          <a:bodyPr/>
+          <a:lstStyle/>
+          <a:p>
+            <a:endParaRPr/>
+          </a:p>
         </p:txBody>
       </p:sp>
     </p:spTree>
   </p:cSld>
   <p:clrMapOvr>
-    <a:masterClrMapping xmlns:a="http://schemas.openxmlformats.org/drawingml/2006/main"/>
+    <a:masterClrMapping/>
   </p:clrMapOvr>
 </p:notes>
 </file>
 
 <file path=ppt/slideLayouts/slideLayout1.xml><?xml version="1.0" encoding="utf-8"?>
-<p:sldLayout xmlns:p="http://schemas.openxmlformats.org/presentationml/2006/main" type="title">
+<p:sldLayout xmlns:a="http://schemas.openxmlformats.org/drawingml/2006/main" xmlns:r="http://schemas.openxmlformats.org/officeDocument/2006/relationships" xmlns:p="http://schemas.openxmlformats.org/presentationml/2006/main" type="title">
   <p:cSld name="Title Slide">
     <p:spTree>
       <p:nvGrpSpPr>
@@ -624,43 +524,48 @@
         <p:nvPr/>
       </p:nvGrpSpPr>
       <p:grpSpPr>
-        <a:xfrm xmlns:a="http://schemas.openxmlformats.org/drawingml/2006/main"/>
+        <a:xfrm>
+          <a:off x="0" y="0"/>
+          <a:ext cx="0" cy="0"/>
+          <a:chOff x="0" y="0"/>
+          <a:chExt cx="0" cy="0"/>
+        </a:xfrm>
       </p:grpSpPr>
       <p:sp>
         <p:nvSpPr>
           <p:cNvPr id="3" name="Title">
-            <a:extLst xmlns:a="http://schemas.openxmlformats.org/drawingml/2006/main">
+            <a:extLst>
               <a:ext uri="{FF2B5EF4-FFF2-40B4-BE49-F238E27FC236}">
                 <a16:creationId xmlns:a16="http://schemas.microsoft.com/office/drawing/2014/main" id="{CF239E88-8259-4795-BCA7-2B98CF226572}"/>
               </a:ext>
             </a:extLst>
           </p:cNvPr>
           <p:cNvSpPr>
-            <a:spLocks xmlns:a="http://schemas.openxmlformats.org/drawingml/2006/main" noGrp="1"/>
+            <a:spLocks noGrp="1"/>
           </p:cNvSpPr>
           <p:nvPr>
-            <p:ph type="title" idx="0"/>
+            <p:ph type="title"/>
           </p:nvPr>
         </p:nvSpPr>
         <p:spPr>
-          <a:xfrm xmlns:a="http://schemas.openxmlformats.org/drawingml/2006/main">
+          <a:xfrm>
             <a:off x="1219200" y="2590800"/>
             <a:ext cx="9753600" cy="990600"/>
           </a:xfrm>
-          <a:prstGeom xmlns:a="http://schemas.openxmlformats.org/drawingml/2006/main" prst="rect">
+          <a:prstGeom prst="rect">
             <a:avLst/>
           </a:prstGeom>
-          <a:noFill xmlns:a="http://schemas.openxmlformats.org/drawingml/2006/main"/>
-          <a:ln xmlns:a="http://schemas.openxmlformats.org/drawingml/2006/main">
+          <a:noFill/>
+          <a:ln>
             <a:noFill/>
             <a:prstDash val="solid"/>
           </a:ln>
         </p:spPr>
         <p:txBody>
-          <a:bodyPr xmlns:a="http://schemas.openxmlformats.org/drawingml/2006/main" wrap="square" lIns="0" tIns="0" rIns="0" bIns="0" anchor="ctr">
+          <a:bodyPr wrap="square" lIns="0" tIns="0" rIns="0" bIns="0" anchor="ctr">
             <a:normAutofit/>
           </a:bodyPr>
-          <a:lstStyle xmlns:a="http://schemas.openxmlformats.org/drawingml/2006/main">
+          <a:lstStyle>
             <a:defPPr algn="ctr">
               <a:defRPr sz="4800" b="1">
                 <a:solidFill>
@@ -852,44 +757,46 @@
               </a:defRPr>
             </a:lvl9pPr>
           </a:lstStyle>
-          <a:p xmlns:a="http://schemas.openxmlformats.org/drawingml/2006/main"/>
+          <a:p>
+            <a:endParaRPr/>
+          </a:p>
         </p:txBody>
       </p:sp>
       <p:sp>
         <p:nvSpPr>
           <p:cNvPr id="2" name="Subtitle">
-            <a:extLst xmlns:a="http://schemas.openxmlformats.org/drawingml/2006/main">
+            <a:extLst>
               <a:ext uri="{FF2B5EF4-FFF2-40B4-BE49-F238E27FC236}">
                 <a16:creationId xmlns:a16="http://schemas.microsoft.com/office/drawing/2014/main" id="{BAA95FF4-EA81-4986-8C97-9B4281BD2634}"/>
               </a:ext>
             </a:extLst>
           </p:cNvPr>
           <p:cNvSpPr>
-            <a:spLocks xmlns:a="http://schemas.openxmlformats.org/drawingml/2006/main" noGrp="1"/>
+            <a:spLocks noGrp="1"/>
           </p:cNvSpPr>
           <p:nvPr>
             <p:ph type="subTitle" idx="1"/>
           </p:nvPr>
         </p:nvSpPr>
         <p:spPr>
-          <a:xfrm xmlns:a="http://schemas.openxmlformats.org/drawingml/2006/main">
+          <a:xfrm>
             <a:off x="1828800" y="3771900"/>
             <a:ext cx="8534400" cy="762000"/>
           </a:xfrm>
-          <a:prstGeom xmlns:a="http://schemas.openxmlformats.org/drawingml/2006/main" prst="rect">
+          <a:prstGeom prst="rect">
             <a:avLst/>
           </a:prstGeom>
-          <a:noFill xmlns:a="http://schemas.openxmlformats.org/drawingml/2006/main"/>
-          <a:ln xmlns:a="http://schemas.openxmlformats.org/drawingml/2006/main">
+          <a:noFill/>
+          <a:ln>
             <a:noFill/>
             <a:prstDash val="solid"/>
           </a:ln>
         </p:spPr>
         <p:txBody>
-          <a:bodyPr xmlns:a="http://schemas.openxmlformats.org/drawingml/2006/main" wrap="square" lIns="0" tIns="0" rIns="0" bIns="0" anchor="ctr">
+          <a:bodyPr wrap="square" lIns="0" tIns="0" rIns="0" bIns="0" anchor="ctr">
             <a:normAutofit/>
           </a:bodyPr>
-          <a:lstStyle xmlns:a="http://schemas.openxmlformats.org/drawingml/2006/main">
+          <a:lstStyle>
             <a:defPPr algn="ctr">
               <a:defRPr sz="2100" b="0">
                 <a:solidFill>
@@ -1081,16 +988,21 @@
               </a:defRPr>
             </a:lvl9pPr>
           </a:lstStyle>
-          <a:p xmlns:a="http://schemas.openxmlformats.org/drawingml/2006/main"/>
+          <a:p>
+            <a:endParaRPr/>
+          </a:p>
         </p:txBody>
       </p:sp>
     </p:spTree>
   </p:cSld>
+  <p:clrMapOvr>
+    <a:masterClrMapping/>
+  </p:clrMapOvr>
 </p:sldLayout>
 </file>
 
 <file path=ppt/slideLayouts/slideLayout2.xml><?xml version="1.0" encoding="utf-8"?>
-<p:sldLayout xmlns:p="http://schemas.openxmlformats.org/presentationml/2006/main">
+<p:sldLayout xmlns:a="http://schemas.openxmlformats.org/drawingml/2006/main" xmlns:r="http://schemas.openxmlformats.org/officeDocument/2006/relationships" xmlns:p="http://schemas.openxmlformats.org/presentationml/2006/main">
   <p:cSld name="Section Header">
     <p:spTree>
       <p:nvGrpSpPr>
@@ -1099,43 +1011,48 @@
         <p:nvPr/>
       </p:nvGrpSpPr>
       <p:grpSpPr>
-        <a:xfrm xmlns:a="http://schemas.openxmlformats.org/drawingml/2006/main"/>
+        <a:xfrm>
+          <a:off x="0" y="0"/>
+          <a:ext cx="0" cy="0"/>
+          <a:chOff x="0" y="0"/>
+          <a:chExt cx="0" cy="0"/>
+        </a:xfrm>
       </p:grpSpPr>
       <p:sp>
         <p:nvSpPr>
           <p:cNvPr id="2" name="Section title">
-            <a:extLst xmlns:a="http://schemas.openxmlformats.org/drawingml/2006/main">
+            <a:extLst>
               <a:ext uri="{FF2B5EF4-FFF2-40B4-BE49-F238E27FC236}">
                 <a16:creationId xmlns:a16="http://schemas.microsoft.com/office/drawing/2014/main" id="{B01BBF64-6556-4EA3-984B-46718E768B13}"/>
               </a:ext>
             </a:extLst>
           </p:cNvPr>
           <p:cNvSpPr>
-            <a:spLocks xmlns:a="http://schemas.openxmlformats.org/drawingml/2006/main" noGrp="1"/>
+            <a:spLocks noGrp="1"/>
           </p:cNvSpPr>
           <p:nvPr>
-            <p:ph type="title" idx="0"/>
+            <p:ph type="title"/>
           </p:nvPr>
         </p:nvSpPr>
         <p:spPr>
-          <a:xfrm xmlns:a="http://schemas.openxmlformats.org/drawingml/2006/main">
+          <a:xfrm>
             <a:off x="1219200" y="2857500"/>
             <a:ext cx="9753600" cy="1143000"/>
           </a:xfrm>
-          <a:prstGeom xmlns:a="http://schemas.openxmlformats.org/drawingml/2006/main" prst="rect">
+          <a:prstGeom prst="rect">
             <a:avLst/>
           </a:prstGeom>
-          <a:noFill xmlns:a="http://schemas.openxmlformats.org/drawingml/2006/main"/>
-          <a:ln xmlns:a="http://schemas.openxmlformats.org/drawingml/2006/main">
+          <a:noFill/>
+          <a:ln>
             <a:noFill/>
             <a:prstDash val="solid"/>
           </a:ln>
         </p:spPr>
         <p:txBody>
-          <a:bodyPr xmlns:a="http://schemas.openxmlformats.org/drawingml/2006/main" wrap="square" lIns="0" tIns="0" rIns="0" bIns="0" anchor="ctr">
+          <a:bodyPr wrap="square" lIns="0" tIns="0" rIns="0" bIns="0" anchor="ctr">
             <a:normAutofit/>
           </a:bodyPr>
-          <a:lstStyle xmlns:a="http://schemas.openxmlformats.org/drawingml/2006/main">
+          <a:lstStyle>
             <a:defPPr algn="ctr">
               <a:defRPr sz="4200" b="1">
                 <a:solidFill>
@@ -1327,16 +1244,21 @@
               </a:defRPr>
             </a:lvl9pPr>
           </a:lstStyle>
-          <a:p xmlns:a="http://schemas.openxmlformats.org/drawingml/2006/main"/>
+          <a:p>
+            <a:endParaRPr/>
+          </a:p>
         </p:txBody>
       </p:sp>
     </p:spTree>
   </p:cSld>
+  <p:clrMapOvr>
+    <a:masterClrMapping/>
+  </p:clrMapOvr>
 </p:sldLayout>
 </file>
 
 <file path=ppt/slideLayouts/slideLayout3.xml><?xml version="1.0" encoding="utf-8"?>
-<p:sldLayout xmlns:p="http://schemas.openxmlformats.org/presentationml/2006/main">
+<p:sldLayout xmlns:a="http://schemas.openxmlformats.org/drawingml/2006/main" xmlns:r="http://schemas.openxmlformats.org/officeDocument/2006/relationships" xmlns:p="http://schemas.openxmlformats.org/presentationml/2006/main">
   <p:cSld name="Title and Body">
     <p:spTree>
       <p:nvGrpSpPr>
@@ -1345,43 +1267,48 @@
         <p:nvPr/>
       </p:nvGrpSpPr>
       <p:grpSpPr>
-        <a:xfrm xmlns:a="http://schemas.openxmlformats.org/drawingml/2006/main"/>
+        <a:xfrm>
+          <a:off x="0" y="0"/>
+          <a:ext cx="0" cy="0"/>
+          <a:chOff x="0" y="0"/>
+          <a:chExt cx="0" cy="0"/>
+        </a:xfrm>
       </p:grpSpPr>
       <p:sp>
         <p:nvSpPr>
           <p:cNvPr id="3" name="Title">
-            <a:extLst xmlns:a="http://schemas.openxmlformats.org/drawingml/2006/main">
+            <a:extLst>
               <a:ext uri="{FF2B5EF4-FFF2-40B4-BE49-F238E27FC236}">
                 <a16:creationId xmlns:a16="http://schemas.microsoft.com/office/drawing/2014/main" id="{BE4F7466-1883-410A-B291-8257A35809E1}"/>
               </a:ext>
             </a:extLst>
           </p:cNvPr>
           <p:cNvSpPr>
-            <a:spLocks xmlns:a="http://schemas.openxmlformats.org/drawingml/2006/main" noGrp="1"/>
+            <a:spLocks noGrp="1"/>
           </p:cNvSpPr>
           <p:nvPr>
-            <p:ph type="title" idx="0"/>
+            <p:ph type="title"/>
           </p:nvPr>
         </p:nvSpPr>
         <p:spPr>
-          <a:xfrm xmlns:a="http://schemas.openxmlformats.org/drawingml/2006/main">
+          <a:xfrm>
             <a:off x="685800" y="533400"/>
             <a:ext cx="10820400" cy="838200"/>
           </a:xfrm>
-          <a:prstGeom xmlns:a="http://schemas.openxmlformats.org/drawingml/2006/main" prst="rect">
+          <a:prstGeom prst="rect">
             <a:avLst/>
           </a:prstGeom>
-          <a:noFill xmlns:a="http://schemas.openxmlformats.org/drawingml/2006/main"/>
-          <a:ln xmlns:a="http://schemas.openxmlformats.org/drawingml/2006/main">
+          <a:noFill/>
+          <a:ln>
             <a:noFill/>
             <a:prstDash val="solid"/>
           </a:ln>
         </p:spPr>
         <p:txBody>
-          <a:bodyPr xmlns:a="http://schemas.openxmlformats.org/drawingml/2006/main" wrap="square" lIns="0" tIns="0" rIns="0" bIns="0" anchor="t">
+          <a:bodyPr wrap="square" lIns="0" tIns="0" rIns="0" bIns="0" anchor="t">
             <a:normAutofit/>
           </a:bodyPr>
-          <a:lstStyle xmlns:a="http://schemas.openxmlformats.org/drawingml/2006/main">
+          <a:lstStyle>
             <a:defPPr algn="l">
               <a:defRPr sz="3300" b="1">
                 <a:solidFill>
@@ -1573,44 +1500,46 @@
               </a:defRPr>
             </a:lvl9pPr>
           </a:lstStyle>
-          <a:p xmlns:a="http://schemas.openxmlformats.org/drawingml/2006/main"/>
+          <a:p>
+            <a:endParaRPr/>
+          </a:p>
         </p:txBody>
       </p:sp>
       <p:sp>
         <p:nvSpPr>
           <p:cNvPr id="2" name="Body">
-            <a:extLst xmlns:a="http://schemas.openxmlformats.org/drawingml/2006/main">
+            <a:extLst>
               <a:ext uri="{FF2B5EF4-FFF2-40B4-BE49-F238E27FC236}">
                 <a16:creationId xmlns:a16="http://schemas.microsoft.com/office/drawing/2014/main" id="{8C9C24C2-2654-4D3C-B0CB-A503BBFBB17A}"/>
               </a:ext>
             </a:extLst>
           </p:cNvPr>
           <p:cNvSpPr>
-            <a:spLocks xmlns:a="http://schemas.openxmlformats.org/drawingml/2006/main" noGrp="1"/>
+            <a:spLocks noGrp="1"/>
           </p:cNvSpPr>
           <p:nvPr>
             <p:ph type="body" idx="1"/>
           </p:nvPr>
         </p:nvSpPr>
         <p:spPr>
-          <a:xfrm xmlns:a="http://schemas.openxmlformats.org/drawingml/2006/main">
+          <a:xfrm>
             <a:off x="685800" y="1905000"/>
             <a:ext cx="10820400" cy="4267200"/>
           </a:xfrm>
-          <a:prstGeom xmlns:a="http://schemas.openxmlformats.org/drawingml/2006/main" prst="rect">
+          <a:prstGeom prst="rect">
             <a:avLst/>
           </a:prstGeom>
-          <a:noFill xmlns:a="http://schemas.openxmlformats.org/drawingml/2006/main"/>
-          <a:ln xmlns:a="http://schemas.openxmlformats.org/drawingml/2006/main">
+          <a:noFill/>
+          <a:ln>
             <a:noFill/>
             <a:prstDash val="solid"/>
           </a:ln>
         </p:spPr>
         <p:txBody>
-          <a:bodyPr xmlns:a="http://schemas.openxmlformats.org/drawingml/2006/main" wrap="square" lIns="0" tIns="0" rIns="0" bIns="0" anchor="t">
+          <a:bodyPr wrap="square" lIns="0" tIns="0" rIns="0" bIns="0" anchor="t">
             <a:normAutofit/>
           </a:bodyPr>
-          <a:lstStyle xmlns:a="http://schemas.openxmlformats.org/drawingml/2006/main">
+          <a:lstStyle>
             <a:defPPr algn="l">
               <a:defRPr sz="2250" b="0">
                 <a:solidFill>
@@ -1802,16 +1731,21 @@
               </a:defRPr>
             </a:lvl9pPr>
           </a:lstStyle>
-          <a:p xmlns:a="http://schemas.openxmlformats.org/drawingml/2006/main"/>
+          <a:p>
+            <a:endParaRPr/>
+          </a:p>
         </p:txBody>
       </p:sp>
     </p:spTree>
   </p:cSld>
+  <p:clrMapOvr>
+    <a:masterClrMapping/>
+  </p:clrMapOvr>
 </p:sldLayout>
 </file>
 
 <file path=ppt/slideLayouts/slideLayout4.xml><?xml version="1.0" encoding="utf-8"?>
-<p:sldLayout xmlns:p="http://schemas.openxmlformats.org/presentationml/2006/main">
+<p:sldLayout xmlns:a="http://schemas.openxmlformats.org/drawingml/2006/main" xmlns:r="http://schemas.openxmlformats.org/officeDocument/2006/relationships" xmlns:p="http://schemas.openxmlformats.org/presentationml/2006/main">
   <p:cSld name="Title and Two Column">
     <p:spTree>
       <p:nvGrpSpPr>
@@ -1820,43 +1754,48 @@
         <p:nvPr/>
       </p:nvGrpSpPr>
       <p:grpSpPr>
-        <a:xfrm xmlns:a="http://schemas.openxmlformats.org/drawingml/2006/main"/>
+        <a:xfrm>
+          <a:off x="0" y="0"/>
+          <a:ext cx="0" cy="0"/>
+          <a:chOff x="0" y="0"/>
+          <a:chExt cx="0" cy="0"/>
+        </a:xfrm>
       </p:grpSpPr>
       <p:sp>
         <p:nvSpPr>
           <p:cNvPr id="4" name="Title">
-            <a:extLst xmlns:a="http://schemas.openxmlformats.org/drawingml/2006/main">
+            <a:extLst>
               <a:ext uri="{FF2B5EF4-FFF2-40B4-BE49-F238E27FC236}">
                 <a16:creationId xmlns:a16="http://schemas.microsoft.com/office/drawing/2014/main" id="{60DE0972-94B6-430E-8256-A9D05ABC430E}"/>
               </a:ext>
             </a:extLst>
           </p:cNvPr>
           <p:cNvSpPr>
-            <a:spLocks xmlns:a="http://schemas.openxmlformats.org/drawingml/2006/main" noGrp="1"/>
+            <a:spLocks noGrp="1"/>
           </p:cNvSpPr>
           <p:nvPr>
-            <p:ph type="title" idx="0"/>
+            <p:ph type="title"/>
           </p:nvPr>
         </p:nvSpPr>
         <p:spPr>
-          <a:xfrm xmlns:a="http://schemas.openxmlformats.org/drawingml/2006/main">
+          <a:xfrm>
             <a:off x="685800" y="533400"/>
             <a:ext cx="10820400" cy="838200"/>
           </a:xfrm>
-          <a:prstGeom xmlns:a="http://schemas.openxmlformats.org/drawingml/2006/main" prst="rect">
+          <a:prstGeom prst="rect">
             <a:avLst/>
           </a:prstGeom>
-          <a:noFill xmlns:a="http://schemas.openxmlformats.org/drawingml/2006/main"/>
-          <a:ln xmlns:a="http://schemas.openxmlformats.org/drawingml/2006/main">
+          <a:noFill/>
+          <a:ln>
             <a:noFill/>
             <a:prstDash val="solid"/>
           </a:ln>
         </p:spPr>
         <p:txBody>
-          <a:bodyPr xmlns:a="http://schemas.openxmlformats.org/drawingml/2006/main" wrap="square" lIns="0" tIns="0" rIns="0" bIns="0" anchor="t">
+          <a:bodyPr wrap="square" lIns="0" tIns="0" rIns="0" bIns="0" anchor="t">
             <a:normAutofit/>
           </a:bodyPr>
-          <a:lstStyle xmlns:a="http://schemas.openxmlformats.org/drawingml/2006/main">
+          <a:lstStyle>
             <a:defPPr algn="l">
               <a:defRPr sz="3300" b="1">
                 <a:solidFill>
@@ -2048,44 +1987,46 @@
               </a:defRPr>
             </a:lvl9pPr>
           </a:lstStyle>
-          <a:p xmlns:a="http://schemas.openxmlformats.org/drawingml/2006/main"/>
+          <a:p>
+            <a:endParaRPr/>
+          </a:p>
         </p:txBody>
       </p:sp>
       <p:sp>
         <p:nvSpPr>
           <p:cNvPr id="2" name="Left column">
-            <a:extLst xmlns:a="http://schemas.openxmlformats.org/drawingml/2006/main">
+            <a:extLst>
               <a:ext uri="{FF2B5EF4-FFF2-40B4-BE49-F238E27FC236}">
                 <a16:creationId xmlns:a16="http://schemas.microsoft.com/office/drawing/2014/main" id="{AF7E1F04-DCD2-4D50-92BA-50E88A66F9C1}"/>
               </a:ext>
             </a:extLst>
           </p:cNvPr>
           <p:cNvSpPr>
-            <a:spLocks xmlns:a="http://schemas.openxmlformats.org/drawingml/2006/main" noGrp="1"/>
+            <a:spLocks noGrp="1"/>
           </p:cNvSpPr>
           <p:nvPr>
             <p:ph type="body" idx="1"/>
           </p:nvPr>
         </p:nvSpPr>
         <p:spPr>
-          <a:xfrm xmlns:a="http://schemas.openxmlformats.org/drawingml/2006/main">
+          <a:xfrm>
             <a:off x="685800" y="1905000"/>
             <a:ext cx="5029200" cy="4267200"/>
           </a:xfrm>
-          <a:prstGeom xmlns:a="http://schemas.openxmlformats.org/drawingml/2006/main" prst="rect">
+          <a:prstGeom prst="rect">
             <a:avLst/>
           </a:prstGeom>
-          <a:noFill xmlns:a="http://schemas.openxmlformats.org/drawingml/2006/main"/>
-          <a:ln xmlns:a="http://schemas.openxmlformats.org/drawingml/2006/main">
+          <a:noFill/>
+          <a:ln>
             <a:noFill/>
             <a:prstDash val="solid"/>
           </a:ln>
         </p:spPr>
         <p:txBody>
-          <a:bodyPr xmlns:a="http://schemas.openxmlformats.org/drawingml/2006/main" wrap="square" lIns="0" tIns="0" rIns="0" bIns="0" anchor="t">
+          <a:bodyPr wrap="square" lIns="0" tIns="0" rIns="0" bIns="0" anchor="t">
             <a:normAutofit/>
           </a:bodyPr>
-          <a:lstStyle xmlns:a="http://schemas.openxmlformats.org/drawingml/2006/main">
+          <a:lstStyle>
             <a:defPPr algn="l">
               <a:defRPr sz="2100" b="0">
                 <a:solidFill>
@@ -2277,44 +2218,46 @@
               </a:defRPr>
             </a:lvl9pPr>
           </a:lstStyle>
-          <a:p xmlns:a="http://schemas.openxmlformats.org/drawingml/2006/main"/>
+          <a:p>
+            <a:endParaRPr/>
+          </a:p>
         </p:txBody>
       </p:sp>
       <p:sp>
         <p:nvSpPr>
           <p:cNvPr id="3" name="Right column">
-            <a:extLst xmlns:a="http://schemas.openxmlformats.org/drawingml/2006/main">
+            <a:extLst>
               <a:ext uri="{FF2B5EF4-FFF2-40B4-BE49-F238E27FC236}">
                 <a16:creationId xmlns:a16="http://schemas.microsoft.com/office/drawing/2014/main" id="{1EE8C9C0-2C1A-4559-8B30-7CBAA2D371E6}"/>
               </a:ext>
             </a:extLst>
           </p:cNvPr>
           <p:cNvSpPr>
-            <a:spLocks xmlns:a="http://schemas.openxmlformats.org/drawingml/2006/main" noGrp="1"/>
+            <a:spLocks noGrp="1"/>
           </p:cNvSpPr>
           <p:nvPr>
             <p:ph type="body" idx="2"/>
           </p:nvPr>
         </p:nvSpPr>
         <p:spPr>
-          <a:xfrm xmlns:a="http://schemas.openxmlformats.org/drawingml/2006/main">
+          <a:xfrm>
             <a:off x="6477000" y="1905000"/>
             <a:ext cx="5029200" cy="4267200"/>
           </a:xfrm>
-          <a:prstGeom xmlns:a="http://schemas.openxmlformats.org/drawingml/2006/main" prst="rect">
+          <a:prstGeom prst="rect">
             <a:avLst/>
           </a:prstGeom>
-          <a:noFill xmlns:a="http://schemas.openxmlformats.org/drawingml/2006/main"/>
-          <a:ln xmlns:a="http://schemas.openxmlformats.org/drawingml/2006/main">
+          <a:noFill/>
+          <a:ln>
             <a:noFill/>
             <a:prstDash val="solid"/>
           </a:ln>
         </p:spPr>
         <p:txBody>
-          <a:bodyPr xmlns:a="http://schemas.openxmlformats.org/drawingml/2006/main" wrap="square" lIns="0" tIns="0" rIns="0" bIns="0" anchor="t">
+          <a:bodyPr wrap="square" lIns="0" tIns="0" rIns="0" bIns="0" anchor="t">
             <a:normAutofit/>
           </a:bodyPr>
-          <a:lstStyle xmlns:a="http://schemas.openxmlformats.org/drawingml/2006/main">
+          <a:lstStyle>
             <a:defPPr algn="l">
               <a:defRPr sz="2100" b="0">
                 <a:solidFill>
@@ -2506,16 +2449,21 @@
               </a:defRPr>
             </a:lvl9pPr>
           </a:lstStyle>
-          <a:p xmlns:a="http://schemas.openxmlformats.org/drawingml/2006/main"/>
+          <a:p>
+            <a:endParaRPr/>
+          </a:p>
         </p:txBody>
       </p:sp>
     </p:spTree>
   </p:cSld>
+  <p:clrMapOvr>
+    <a:masterClrMapping/>
+  </p:clrMapOvr>
 </p:sldLayout>
 </file>
 
 <file path=ppt/slideLayouts/slideLayout5.xml><?xml version="1.0" encoding="utf-8"?>
-<p:sldLayout xmlns:p="http://schemas.openxmlformats.org/presentationml/2006/main">
+<p:sldLayout xmlns:a="http://schemas.openxmlformats.org/drawingml/2006/main" xmlns:r="http://schemas.openxmlformats.org/officeDocument/2006/relationships" xmlns:p="http://schemas.openxmlformats.org/presentationml/2006/main">
   <p:cSld name="Title and One Column">
     <p:spTree>
       <p:nvGrpSpPr>
@@ -2524,43 +2472,48 @@
         <p:nvPr/>
       </p:nvGrpSpPr>
       <p:grpSpPr>
-        <a:xfrm xmlns:a="http://schemas.openxmlformats.org/drawingml/2006/main"/>
+        <a:xfrm>
+          <a:off x="0" y="0"/>
+          <a:ext cx="0" cy="0"/>
+          <a:chOff x="0" y="0"/>
+          <a:chExt cx="0" cy="0"/>
+        </a:xfrm>
       </p:grpSpPr>
       <p:sp>
         <p:nvSpPr>
           <p:cNvPr id="3" name="Title">
-            <a:extLst xmlns:a="http://schemas.openxmlformats.org/drawingml/2006/main">
+            <a:extLst>
               <a:ext uri="{FF2B5EF4-FFF2-40B4-BE49-F238E27FC236}">
                 <a16:creationId xmlns:a16="http://schemas.microsoft.com/office/drawing/2014/main" id="{A4202758-A8DF-4B2A-BC3E-57ACA8F0905E}"/>
               </a:ext>
             </a:extLst>
           </p:cNvPr>
           <p:cNvSpPr>
-            <a:spLocks xmlns:a="http://schemas.openxmlformats.org/drawingml/2006/main" noGrp="1"/>
+            <a:spLocks noGrp="1"/>
           </p:cNvSpPr>
           <p:nvPr>
-            <p:ph type="title" idx="0"/>
+            <p:ph type="title"/>
           </p:nvPr>
         </p:nvSpPr>
         <p:spPr>
-          <a:xfrm xmlns:a="http://schemas.openxmlformats.org/drawingml/2006/main">
+          <a:xfrm>
             <a:off x="685800" y="533400"/>
             <a:ext cx="10820400" cy="838200"/>
           </a:xfrm>
-          <a:prstGeom xmlns:a="http://schemas.openxmlformats.org/drawingml/2006/main" prst="rect">
+          <a:prstGeom prst="rect">
             <a:avLst/>
           </a:prstGeom>
-          <a:noFill xmlns:a="http://schemas.openxmlformats.org/drawingml/2006/main"/>
-          <a:ln xmlns:a="http://schemas.openxmlformats.org/drawingml/2006/main">
+          <a:noFill/>
+          <a:ln>
             <a:noFill/>
             <a:prstDash val="solid"/>
           </a:ln>
         </p:spPr>
         <p:txBody>
-          <a:bodyPr xmlns:a="http://schemas.openxmlformats.org/drawingml/2006/main" wrap="square" lIns="0" tIns="0" rIns="0" bIns="0" anchor="t">
+          <a:bodyPr wrap="square" lIns="0" tIns="0" rIns="0" bIns="0" anchor="t">
             <a:normAutofit/>
           </a:bodyPr>
-          <a:lstStyle xmlns:a="http://schemas.openxmlformats.org/drawingml/2006/main">
+          <a:lstStyle>
             <a:defPPr algn="l">
               <a:defRPr sz="3300" b="1">
                 <a:solidFill>
@@ -2752,44 +2705,46 @@
               </a:defRPr>
             </a:lvl9pPr>
           </a:lstStyle>
-          <a:p xmlns:a="http://schemas.openxmlformats.org/drawingml/2006/main"/>
+          <a:p>
+            <a:endParaRPr/>
+          </a:p>
         </p:txBody>
       </p:sp>
       <p:sp>
         <p:nvSpPr>
           <p:cNvPr id="2" name="Left column">
-            <a:extLst xmlns:a="http://schemas.openxmlformats.org/drawingml/2006/main">
+            <a:extLst>
               <a:ext uri="{FF2B5EF4-FFF2-40B4-BE49-F238E27FC236}">
                 <a16:creationId xmlns:a16="http://schemas.microsoft.com/office/drawing/2014/main" id="{CDF74385-2A27-46CD-9FB4-907B55B80554}"/>
               </a:ext>
             </a:extLst>
           </p:cNvPr>
           <p:cNvSpPr>
-            <a:spLocks xmlns:a="http://schemas.openxmlformats.org/drawingml/2006/main" noGrp="1"/>
+            <a:spLocks noGrp="1"/>
           </p:cNvSpPr>
           <p:nvPr>
             <p:ph type="body" idx="1"/>
           </p:nvPr>
         </p:nvSpPr>
         <p:spPr>
-          <a:xfrm xmlns:a="http://schemas.openxmlformats.org/drawingml/2006/main">
+          <a:xfrm>
             <a:off x="685800" y="1905000"/>
             <a:ext cx="5029200" cy="4267200"/>
           </a:xfrm>
-          <a:prstGeom xmlns:a="http://schemas.openxmlformats.org/drawingml/2006/main" prst="rect">
+          <a:prstGeom prst="rect">
             <a:avLst/>
           </a:prstGeom>
-          <a:noFill xmlns:a="http://schemas.openxmlformats.org/drawingml/2006/main"/>
-          <a:ln xmlns:a="http://schemas.openxmlformats.org/drawingml/2006/main">
+          <a:noFill/>
+          <a:ln>
             <a:noFill/>
             <a:prstDash val="solid"/>
           </a:ln>
         </p:spPr>
         <p:txBody>
-          <a:bodyPr xmlns:a="http://schemas.openxmlformats.org/drawingml/2006/main" wrap="square" lIns="0" tIns="0" rIns="0" bIns="0" anchor="t">
+          <a:bodyPr wrap="square" lIns="0" tIns="0" rIns="0" bIns="0" anchor="t">
             <a:normAutofit/>
           </a:bodyPr>
-          <a:lstStyle xmlns:a="http://schemas.openxmlformats.org/drawingml/2006/main">
+          <a:lstStyle>
             <a:defPPr algn="l">
               <a:defRPr sz="2250" b="0">
                 <a:solidFill>
@@ -2981,16 +2936,21 @@
               </a:defRPr>
             </a:lvl9pPr>
           </a:lstStyle>
-          <a:p xmlns:a="http://schemas.openxmlformats.org/drawingml/2006/main"/>
+          <a:p>
+            <a:endParaRPr/>
+          </a:p>
         </p:txBody>
       </p:sp>
     </p:spTree>
   </p:cSld>
+  <p:clrMapOvr>
+    <a:masterClrMapping/>
+  </p:clrMapOvr>
 </p:sldLayout>
 </file>
 
 <file path=ppt/slideLayouts/slideLayout6.xml><?xml version="1.0" encoding="utf-8"?>
-<p:sldLayout xmlns:p="http://schemas.openxmlformats.org/presentationml/2006/main" type="blank">
+<p:sldLayout xmlns:a="http://schemas.openxmlformats.org/drawingml/2006/main" xmlns:r="http://schemas.openxmlformats.org/officeDocument/2006/relationships" xmlns:p="http://schemas.openxmlformats.org/presentationml/2006/main" type="blank">
   <p:cSld name="Blank">
     <p:spTree>
       <p:nvGrpSpPr>
@@ -2999,19 +2959,27 @@
         <p:nvPr/>
       </p:nvGrpSpPr>
       <p:grpSpPr>
-        <a:xfrm xmlns:a="http://schemas.openxmlformats.org/drawingml/2006/main"/>
+        <a:xfrm>
+          <a:off x="0" y="0"/>
+          <a:ext cx="0" cy="0"/>
+          <a:chOff x="0" y="0"/>
+          <a:chExt cx="0" cy="0"/>
+        </a:xfrm>
       </p:grpSpPr>
     </p:spTree>
   </p:cSld>
+  <p:clrMapOvr>
+    <a:masterClrMapping/>
+  </p:clrMapOvr>
 </p:sldLayout>
 </file>
 
 <file path=ppt/slideMasters/slideMaster1.xml><?xml version="1.0" encoding="utf-8"?>
-<p:sldMaster xmlns:p="http://schemas.openxmlformats.org/presentationml/2006/main">
+<p:sldMaster xmlns:a="http://schemas.openxmlformats.org/drawingml/2006/main" xmlns:r="http://schemas.openxmlformats.org/officeDocument/2006/relationships" xmlns:p="http://schemas.openxmlformats.org/presentationml/2006/main">
   <p:cSld name="Master">
     <p:bg>
       <p:bgRef idx="1001">
-        <a:schemeClr xmlns:a="http://schemas.openxmlformats.org/drawingml/2006/main" val="bg1"/>
+        <a:schemeClr val="bg1"/>
       </p:bgRef>
     </p:bg>
     <p:spTree>
@@ -3021,22 +2989,27 @@
         <p:nvPr/>
       </p:nvGrpSpPr>
       <p:grpSpPr>
-        <a:xfrm xmlns:a="http://schemas.openxmlformats.org/drawingml/2006/main"/>
+        <a:xfrm>
+          <a:off x="0" y="0"/>
+          <a:ext cx="0" cy="0"/>
+          <a:chOff x="0" y="0"/>
+          <a:chExt cx="0" cy="0"/>
+        </a:xfrm>
       </p:grpSpPr>
     </p:spTree>
   </p:cSld>
   <p:clrMap bg1="lt1" tx1="dk1" bg2="lt2" tx2="dk2" accent1="accent1" accent2="accent2" accent3="accent3" accent4="accent4" accent5="accent5" accent6="accent6" hlink="hlink" folHlink="folHlink"/>
   <p:sldLayoutIdLst>
-    <p:sldLayoutId xmlns:r="http://schemas.openxmlformats.org/officeDocument/2006/relationships" id="2147483649" r:id="R46c4f6ecf6474585"/>
-    <p:sldLayoutId xmlns:r="http://schemas.openxmlformats.org/officeDocument/2006/relationships" id="2147483650" r:id="R30aae67e968b4502"/>
-    <p:sldLayoutId xmlns:r="http://schemas.openxmlformats.org/officeDocument/2006/relationships" id="2147483651" r:id="Rdef367b33dd74575"/>
-    <p:sldLayoutId xmlns:r="http://schemas.openxmlformats.org/officeDocument/2006/relationships" id="2147483652" r:id="Rb9d1e68e8c594809"/>
-    <p:sldLayoutId xmlns:r="http://schemas.openxmlformats.org/officeDocument/2006/relationships" id="2147483653" r:id="Rc7c5678245074ea2"/>
-    <p:sldLayoutId xmlns:r="http://schemas.openxmlformats.org/officeDocument/2006/relationships" id="2147483654" r:id="R2f4dec45c23e41fa"/>
+    <p:sldLayoutId id="2147483649" r:id="rId1"/>
+    <p:sldLayoutId id="2147483650" r:id="rId2"/>
+    <p:sldLayoutId id="2147483651" r:id="rId3"/>
+    <p:sldLayoutId id="2147483652" r:id="rId4"/>
+    <p:sldLayoutId id="2147483653" r:id="rId5"/>
+    <p:sldLayoutId id="2147483654" r:id="rId6"/>
   </p:sldLayoutIdLst>
   <p:txStyles>
     <p:titleStyle>
-      <a:lvl1pPr xmlns:a="http://schemas.openxmlformats.org/drawingml/2006/main" algn="l">
+      <a:lvl1pPr algn="l">
         <a:lnSpc>
           <a:spcPct val="90000"/>
         </a:lnSpc>
@@ -3055,7 +3028,7 @@
       </a:lvl1pPr>
     </p:titleStyle>
     <p:bodyStyle>
-      <a:lvl1pPr xmlns:a="http://schemas.openxmlformats.org/drawingml/2006/main" marL="228600" indent="-228600" algn="l">
+      <a:lvl1pPr marL="228600" indent="-228600" algn="l">
         <a:lnSpc>
           <a:spcPct val="90000"/>
         </a:lnSpc>
@@ -3072,7 +3045,7 @@
           <a:cs typeface="+mn-lt"/>
         </a:defRPr>
       </a:lvl1pPr>
-      <a:lvl2pPr xmlns:a="http://schemas.openxmlformats.org/drawingml/2006/main" marL="685800" indent="-228600" algn="l">
+      <a:lvl2pPr marL="685800" indent="-228600" algn="l">
         <a:lnSpc>
           <a:spcPct val="90000"/>
         </a:lnSpc>
@@ -3089,7 +3062,7 @@
           <a:cs typeface="+mn-lt"/>
         </a:defRPr>
       </a:lvl2pPr>
-      <a:lvl3pPr xmlns:a="http://schemas.openxmlformats.org/drawingml/2006/main" marL="1143000" indent="-228600" algn="l">
+      <a:lvl3pPr marL="1143000" indent="-228600" algn="l">
         <a:lnSpc>
           <a:spcPct val="90000"/>
         </a:lnSpc>
@@ -3106,7 +3079,7 @@
           <a:cs typeface="+mn-lt"/>
         </a:defRPr>
       </a:lvl3pPr>
-      <a:lvl4pPr xmlns:a="http://schemas.openxmlformats.org/drawingml/2006/main" marL="1600200" indent="-228600" algn="l">
+      <a:lvl4pPr marL="1600200" indent="-228600" algn="l">
         <a:lnSpc>
           <a:spcPct val="90000"/>
         </a:lnSpc>
@@ -3123,7 +3096,7 @@
           <a:cs typeface="+mn-lt"/>
         </a:defRPr>
       </a:lvl4pPr>
-      <a:lvl5pPr xmlns:a="http://schemas.openxmlformats.org/drawingml/2006/main" marL="2057400" indent="-228600" algn="l">
+      <a:lvl5pPr marL="2057400" indent="-228600" algn="l">
         <a:lnSpc>
           <a:spcPct val="90000"/>
         </a:lnSpc>
@@ -3140,7 +3113,7 @@
           <a:cs typeface="+mn-lt"/>
         </a:defRPr>
       </a:lvl5pPr>
-      <a:lvl6pPr xmlns:a="http://schemas.openxmlformats.org/drawingml/2006/main" marL="2514600" indent="-228600" algn="l">
+      <a:lvl6pPr marL="2514600" indent="-228600" algn="l">
         <a:lnSpc>
           <a:spcPct val="90000"/>
         </a:lnSpc>
@@ -3157,7 +3130,7 @@
           <a:cs typeface="+mn-lt"/>
         </a:defRPr>
       </a:lvl6pPr>
-      <a:lvl7pPr xmlns:a="http://schemas.openxmlformats.org/drawingml/2006/main" marL="2971800" indent="-228600" algn="l">
+      <a:lvl7pPr marL="2971800" indent="-228600" algn="l">
         <a:lnSpc>
           <a:spcPct val="90000"/>
         </a:lnSpc>
@@ -3174,7 +3147,7 @@
           <a:cs typeface="+mn-lt"/>
         </a:defRPr>
       </a:lvl7pPr>
-      <a:lvl8pPr xmlns:a="http://schemas.openxmlformats.org/drawingml/2006/main" marL="3429000" indent="-228600" algn="l">
+      <a:lvl8pPr marL="3429000" indent="-228600" algn="l">
         <a:lnSpc>
           <a:spcPct val="90000"/>
         </a:lnSpc>
@@ -3191,7 +3164,7 @@
           <a:cs typeface="+mn-lt"/>
         </a:defRPr>
       </a:lvl8pPr>
-      <a:lvl9pPr xmlns:a="http://schemas.openxmlformats.org/drawingml/2006/main" marL="3886200" indent="-228600" algn="l">
+      <a:lvl9pPr marL="3886200" indent="-228600" algn="l">
         <a:lnSpc>
           <a:spcPct val="90000"/>
         </a:lnSpc>
@@ -3210,7 +3183,7 @@
       </a:lvl9pPr>
     </p:bodyStyle>
     <p:otherStyle>
-      <a:lvl1pPr xmlns:a="http://schemas.openxmlformats.org/drawingml/2006/main" marL="0" algn="l">
+      <a:lvl1pPr marL="0" algn="l">
         <a:buNone/>
         <a:defRPr sz="1800">
           <a:solidFill>
@@ -3221,7 +3194,7 @@
           <a:cs typeface="+mn-lt"/>
         </a:defRPr>
       </a:lvl1pPr>
-      <a:lvl2pPr xmlns:a="http://schemas.openxmlformats.org/drawingml/2006/main" marL="457200" algn="l">
+      <a:lvl2pPr marL="457200" algn="l">
         <a:buNone/>
         <a:defRPr sz="1800">
           <a:solidFill>
@@ -3232,7 +3205,7 @@
           <a:cs typeface="+mn-lt"/>
         </a:defRPr>
       </a:lvl2pPr>
-      <a:lvl3pPr xmlns:a="http://schemas.openxmlformats.org/drawingml/2006/main" marL="914400" algn="l">
+      <a:lvl3pPr marL="914400" algn="l">
         <a:buNone/>
         <a:defRPr sz="1800">
           <a:solidFill>
@@ -3243,7 +3216,7 @@
           <a:cs typeface="+mn-lt"/>
         </a:defRPr>
       </a:lvl3pPr>
-      <a:lvl4pPr xmlns:a="http://schemas.openxmlformats.org/drawingml/2006/main" marL="1371600" algn="l">
+      <a:lvl4pPr marL="1371600" algn="l">
         <a:buNone/>
         <a:defRPr sz="1800">
           <a:solidFill>
@@ -3254,7 +3227,7 @@
           <a:cs typeface="+mn-lt"/>
         </a:defRPr>
       </a:lvl4pPr>
-      <a:lvl5pPr xmlns:a="http://schemas.openxmlformats.org/drawingml/2006/main" marL="1828800" algn="l">
+      <a:lvl5pPr marL="1828800" algn="l">
         <a:buNone/>
         <a:defRPr sz="1800">
           <a:solidFill>
@@ -3265,7 +3238,7 @@
           <a:cs typeface="+mn-lt"/>
         </a:defRPr>
       </a:lvl5pPr>
-      <a:lvl6pPr xmlns:a="http://schemas.openxmlformats.org/drawingml/2006/main" marL="2286000" algn="l">
+      <a:lvl6pPr marL="2286000" algn="l">
         <a:buNone/>
         <a:defRPr sz="1800">
           <a:solidFill>
@@ -3276,7 +3249,7 @@
           <a:cs typeface="+mn-lt"/>
         </a:defRPr>
       </a:lvl6pPr>
-      <a:lvl7pPr xmlns:a="http://schemas.openxmlformats.org/drawingml/2006/main" marL="2743200" algn="l">
+      <a:lvl7pPr marL="2743200" algn="l">
         <a:buNone/>
         <a:defRPr sz="1800">
           <a:solidFill>
@@ -3287,7 +3260,7 @@
           <a:cs typeface="+mn-lt"/>
         </a:defRPr>
       </a:lvl7pPr>
-      <a:lvl8pPr xmlns:a="http://schemas.openxmlformats.org/drawingml/2006/main" marL="3200400" algn="l">
+      <a:lvl8pPr marL="3200400" algn="l">
         <a:buNone/>
         <a:defRPr sz="1800">
           <a:solidFill>
@@ -3298,7 +3271,7 @@
           <a:cs typeface="+mn-lt"/>
         </a:defRPr>
       </a:lvl8pPr>
-      <a:lvl9pPr xmlns:a="http://schemas.openxmlformats.org/drawingml/2006/main" marL="3657600" algn="l">
+      <a:lvl9pPr marL="3657600" algn="l">
         <a:buNone/>
         <a:defRPr sz="1800">
           <a:solidFill>
@@ -3314,259 +3287,15 @@
 </p:sldMaster>
 </file>
 
-<file path=ppt/slideMasters/theme/theme2.xml><?xml version="1.0" encoding="utf-8"?>
-<a:theme xmlns:a="http://schemas.openxmlformats.org/drawingml/2006/main" name="ChatGPT">
-  <a:themeElements>
-    <a:clrScheme name="ChatGPT">
-      <a:dk1>
-        <a:srgbClr val="000000"/>
-      </a:dk1>
-      <a:lt1>
-        <a:srgbClr val="FFFFFF"/>
-      </a:lt1>
-      <a:dk2>
-        <a:srgbClr val="0E2841"/>
-      </a:dk2>
-      <a:lt2>
-        <a:srgbClr val="E8E8E8"/>
-      </a:lt2>
-      <a:accent1>
-        <a:srgbClr val="156082"/>
-      </a:accent1>
-      <a:accent2>
-        <a:srgbClr val="E97132"/>
-      </a:accent2>
-      <a:accent3>
-        <a:srgbClr val="196B24"/>
-      </a:accent3>
-      <a:accent4>
-        <a:srgbClr val="0F9ED5"/>
-      </a:accent4>
-      <a:accent5>
-        <a:srgbClr val="A02B93"/>
-      </a:accent5>
-      <a:accent6>
-        <a:srgbClr val="4EA72E"/>
-      </a:accent6>
-      <a:hlink>
-        <a:srgbClr val="467886"/>
-      </a:hlink>
-      <a:folHlink>
-        <a:srgbClr val="96607D"/>
-      </a:folHlink>
-    </a:clrScheme>
-    <a:fontScheme name="">
-      <a:majorFont>
-        <a:latin typeface="Aptos"/>
-        <a:ea typeface=""/>
-        <a:cs typeface=""/>
-      </a:majorFont>
-      <a:minorFont>
-        <a:latin typeface="Aptos"/>
-        <a:ea typeface=""/>
-        <a:cs typeface=""/>
-      </a:minorFont>
-    </a:fontScheme>
-    <a:fmtScheme name="ChatGPT">
-      <a:fillStyleLst>
-        <a:solidFill>
-          <a:schemeClr val="phClr"/>
-        </a:solidFill>
-        <a:gradFill>
-          <a:gsLst>
-            <a:gs pos="0">
-              <a:schemeClr val="phClr">
-                <a:tint val="67000"/>
-                <a:lumMod val="110000"/>
-                <a:satMod val="105000"/>
-              </a:schemeClr>
-            </a:gs>
-            <a:gs pos="50000">
-              <a:schemeClr val="phClr">
-                <a:tint val="73000"/>
-                <a:lumMod val="105000"/>
-                <a:satMod val="103000"/>
-              </a:schemeClr>
-            </a:gs>
-            <a:gs pos="100000">
-              <a:schemeClr val="phClr">
-                <a:tint val="81000"/>
-                <a:lumMod val="105000"/>
-                <a:satMod val="109000"/>
-              </a:schemeClr>
-            </a:gs>
-          </a:gsLst>
-          <a:lin ang="5400000" scaled="0"/>
-        </a:gradFill>
-        <a:gradFill>
-          <a:gsLst>
-            <a:gs pos="0">
-              <a:schemeClr val="phClr">
-                <a:tint val="94000"/>
-                <a:lumMod val="102000"/>
-                <a:satMod val="103000"/>
-              </a:schemeClr>
-            </a:gs>
-            <a:gs pos="50000">
-              <a:schemeClr val="phClr">
-                <a:shade val="100000"/>
-                <a:lumMod val="100000"/>
-                <a:satMod val="110000"/>
-              </a:schemeClr>
-            </a:gs>
-            <a:gs pos="100000">
-              <a:schemeClr val="phClr">
-                <a:shade val="78000"/>
-                <a:lumMod val="99000"/>
-                <a:satMod val="120000"/>
-              </a:schemeClr>
-            </a:gs>
-          </a:gsLst>
-          <a:lin ang="5400000" scaled="0"/>
-        </a:gradFill>
-      </a:fillStyleLst>
-      <a:lnStyleLst>
-        <a:ln w="12700">
-          <a:solidFill>
-            <a:schemeClr val="phClr"/>
-          </a:solidFill>
-          <a:prstDash val="solid"/>
-        </a:ln>
-        <a:ln w="19050">
-          <a:solidFill>
-            <a:schemeClr val="phClr"/>
-          </a:solidFill>
-          <a:prstDash val="solid"/>
-        </a:ln>
-        <a:ln w="25400">
-          <a:solidFill>
-            <a:schemeClr val="phClr"/>
-          </a:solidFill>
-          <a:prstDash val="solid"/>
-        </a:ln>
-      </a:lnStyleLst>
-      <a:effectStyleLst>
-        <a:effectStyle>
-          <a:effectLst/>
-        </a:effectStyle>
-        <a:effectStyle>
-          <a:effectLst/>
-        </a:effectStyle>
-        <a:effectStyle>
-          <a:effectLst>
-            <a:outerShdw blurRad="57150" dist="19050" dir="5400000">
-              <a:srgbClr val="000000">
-                <a:alpha val="16000"/>
-              </a:srgbClr>
-            </a:outerShdw>
-          </a:effectLst>
-        </a:effectStyle>
-        <a:effectStyle>
-          <a:effectLst>
-            <a:outerShdw blurRad="19050" dist="9525" dir="5400000">
-              <a:srgbClr val="000000">
-                <a:alpha val="6000"/>
-              </a:srgbClr>
-            </a:outerShdw>
-          </a:effectLst>
-        </a:effectStyle>
-        <a:effectStyle>
-          <a:effectLst>
-            <a:outerShdw blurRad="28575" dist="9525" dir="5400000">
-              <a:srgbClr val="000000">
-                <a:alpha val="8000"/>
-              </a:srgbClr>
-            </a:outerShdw>
-          </a:effectLst>
-        </a:effectStyle>
-        <a:effectStyle>
-          <a:effectLst>
-            <a:outerShdw blurRad="57150" dist="19050" dir="5400000">
-              <a:srgbClr val="000000">
-                <a:alpha val="10000"/>
-              </a:srgbClr>
-            </a:outerShdw>
-          </a:effectLst>
-        </a:effectStyle>
-        <a:effectStyle>
-          <a:effectLst>
-            <a:outerShdw blurRad="114300" dist="38100" dir="5400000">
-              <a:srgbClr val="000000">
-                <a:alpha val="12000"/>
-              </a:srgbClr>
-            </a:outerShdw>
-          </a:effectLst>
-        </a:effectStyle>
-        <a:effectStyle>
-          <a:effectLst>
-            <a:outerShdw blurRad="171450" dist="57150" dir="5400000">
-              <a:srgbClr val="000000">
-                <a:alpha val="16000"/>
-              </a:srgbClr>
-            </a:outerShdw>
-          </a:effectLst>
-        </a:effectStyle>
-        <a:effectStyle>
-          <a:effectLst>
-            <a:outerShdw blurRad="266700" dist="95250" dir="5400000">
-              <a:srgbClr val="000000">
-                <a:alpha val="24000"/>
-              </a:srgbClr>
-            </a:outerShdw>
-          </a:effectLst>
-        </a:effectStyle>
-      </a:effectStyleLst>
-      <a:bgFillStyleLst>
-        <a:solidFill>
-          <a:schemeClr val="phClr"/>
-        </a:solidFill>
-        <a:solidFill>
-          <a:schemeClr val="phClr">
-            <a:tint val="95000"/>
-            <a:satMod val="170000"/>
-          </a:schemeClr>
-        </a:solidFill>
-        <a:gradFill>
-          <a:gsLst>
-            <a:gs pos="0">
-              <a:schemeClr val="phClr">
-                <a:tint val="93000"/>
-                <a:shade val="98000"/>
-                <a:lumMod val="102000"/>
-                <a:satMod val="150000"/>
-              </a:schemeClr>
-            </a:gs>
-            <a:gs pos="50000">
-              <a:schemeClr val="phClr">
-                <a:tint val="98000"/>
-                <a:shade val="90000"/>
-                <a:lumMod val="103000"/>
-                <a:satMod val="130000"/>
-              </a:schemeClr>
-            </a:gs>
-            <a:gs pos="100000">
-              <a:schemeClr val="phClr">
-                <a:shade val="63000"/>
-                <a:satMod val="120000"/>
-              </a:schemeClr>
-            </a:gs>
-          </a:gsLst>
-          <a:lin ang="5400000" scaled="0"/>
-        </a:gradFill>
-      </a:bgFillStyleLst>
-    </a:fmtScheme>
-  </a:themeElements>
-</a:theme>
-</file>
-
 <file path=ppt/slides/slide1.xml><?xml version="1.0" encoding="utf-8"?>
-<p:sld xmlns:p="http://schemas.openxmlformats.org/presentationml/2006/main">
+<p:sld xmlns:a="http://schemas.openxmlformats.org/drawingml/2006/main" xmlns:r="http://schemas.openxmlformats.org/officeDocument/2006/relationships" xmlns:p="http://schemas.openxmlformats.org/presentationml/2006/main">
   <p:cSld>
     <p:bg>
       <p:bgPr>
-        <a:solidFill xmlns:a="http://schemas.openxmlformats.org/drawingml/2006/main">
+        <a:solidFill>
           <a:srgbClr val="FFFFFF"/>
         </a:solidFill>
+        <a:effectLst/>
       </p:bgPr>
     </p:bg>
     <p:spTree>
@@ -3576,38 +3305,43 @@
         <p:nvPr/>
       </p:nvGrpSpPr>
       <p:grpSpPr>
-        <a:xfrm xmlns:a="http://schemas.openxmlformats.org/drawingml/2006/main"/>
+        <a:xfrm>
+          <a:off x="0" y="0"/>
+          <a:ext cx="0" cy="0"/>
+          <a:chOff x="0" y="0"/>
+          <a:chExt cx="0" cy="0"/>
+        </a:xfrm>
       </p:grpSpPr>
       <p:sp>
         <p:nvSpPr>
-          <p:cNvPr id="12" name="">
-            <a:extLst xmlns:a="http://schemas.openxmlformats.org/drawingml/2006/main">
+          <p:cNvPr id="12" name="Rectangle 11">
+            <a:extLst>
               <a:ext uri="{FF2B5EF4-FFF2-40B4-BE49-F238E27FC236}">
                 <a16:creationId xmlns:a16="http://schemas.microsoft.com/office/drawing/2014/main" id="{5AE14BCB-2CD9-4DEB-AC0D-CA9DAA7C4EBF}"/>
               </a:ext>
             </a:extLst>
           </p:cNvPr>
           <p:cNvSpPr>
-            <a:spLocks xmlns:a="http://schemas.openxmlformats.org/drawingml/2006/main" noGrp="1"/>
+            <a:spLocks noGrp="1"/>
           </p:cNvSpPr>
           <p:nvPr/>
         </p:nvSpPr>
         <p:spPr>
-          <a:xfrm xmlns:a="http://schemas.openxmlformats.org/drawingml/2006/main">
+          <a:xfrm>
             <a:off x="609600" y="590550"/>
             <a:ext cx="10953750" cy="666750"/>
           </a:xfrm>
-          <a:prstGeom xmlns:a="http://schemas.openxmlformats.org/drawingml/2006/main" prst="rect">
+          <a:prstGeom prst="rect">
             <a:avLst/>
           </a:prstGeom>
-          <a:noFill xmlns:a="http://schemas.openxmlformats.org/drawingml/2006/main"/>
-          <a:ln xmlns:a="http://schemas.openxmlformats.org/drawingml/2006/main" w="0">
+          <a:noFill/>
+          <a:ln w="0">
             <a:noFill/>
           </a:ln>
         </p:spPr>
         <p:txBody>
-          <a:bodyPr xmlns:a="http://schemas.openxmlformats.org/drawingml/2006/main"/>
-          <a:lstStyle xmlns:a="http://schemas.openxmlformats.org/drawingml/2006/main">
+          <a:bodyPr/>
+          <a:lstStyle>
             <a:defPPr>
               <a:defRPr sz="3600" b="1">
                 <a:solidFill>
@@ -3709,7 +3443,7 @@
               </a:defRPr>
             </a:lvl9pPr>
           </a:lstStyle>
-          <a:p xmlns:a="http://schemas.openxmlformats.org/drawingml/2006/main">
+          <a:p>
             <a:pPr>
               <a:defRPr sz="3600" b="1">
                 <a:solidFill>
@@ -3736,34 +3470,34 @@
       </p:sp>
       <p:sp>
         <p:nvSpPr>
-          <p:cNvPr id="2" name="">
-            <a:extLst xmlns:a="http://schemas.openxmlformats.org/drawingml/2006/main">
+          <p:cNvPr id="2" name="Rectangle 1">
+            <a:extLst>
               <a:ext uri="{FF2B5EF4-FFF2-40B4-BE49-F238E27FC236}">
                 <a16:creationId xmlns:a16="http://schemas.microsoft.com/office/drawing/2014/main" id="{D15FA200-0564-4E50-877D-6C7CEE48B251}"/>
               </a:ext>
             </a:extLst>
           </p:cNvPr>
           <p:cNvSpPr>
-            <a:spLocks xmlns:a="http://schemas.openxmlformats.org/drawingml/2006/main" noGrp="1"/>
+            <a:spLocks noGrp="1"/>
           </p:cNvSpPr>
           <p:nvPr/>
         </p:nvSpPr>
         <p:spPr>
-          <a:xfrm xmlns:a="http://schemas.openxmlformats.org/drawingml/2006/main">
+          <a:xfrm>
             <a:off x="609600" y="1390650"/>
             <a:ext cx="10477500" cy="428625"/>
           </a:xfrm>
-          <a:prstGeom xmlns:a="http://schemas.openxmlformats.org/drawingml/2006/main" prst="rect">
+          <a:prstGeom prst="rect">
             <a:avLst/>
           </a:prstGeom>
-          <a:noFill xmlns:a="http://schemas.openxmlformats.org/drawingml/2006/main"/>
-          <a:ln xmlns:a="http://schemas.openxmlformats.org/drawingml/2006/main" w="0">
+          <a:noFill/>
+          <a:ln w="0">
             <a:noFill/>
           </a:ln>
         </p:spPr>
         <p:txBody>
-          <a:bodyPr xmlns:a="http://schemas.openxmlformats.org/drawingml/2006/main"/>
-          <a:lstStyle xmlns:a="http://schemas.openxmlformats.org/drawingml/2006/main">
+          <a:bodyPr/>
+          <a:lstStyle>
             <a:defPPr>
               <a:defRPr sz="2250" b="0">
                 <a:solidFill>
@@ -3865,7 +3599,7 @@
               </a:defRPr>
             </a:lvl9pPr>
           </a:lstStyle>
-          <a:p xmlns:a="http://schemas.openxmlformats.org/drawingml/2006/main">
+          <a:p>
             <a:pPr>
               <a:defRPr sz="2250" b="0">
                 <a:solidFill>
@@ -3892,34 +3626,34 @@
       </p:sp>
       <p:sp>
         <p:nvSpPr>
-          <p:cNvPr id="3" name="">
-            <a:extLst xmlns:a="http://schemas.openxmlformats.org/drawingml/2006/main">
+          <p:cNvPr id="3" name="Rectangle 2">
+            <a:extLst>
               <a:ext uri="{FF2B5EF4-FFF2-40B4-BE49-F238E27FC236}">
                 <a16:creationId xmlns:a16="http://schemas.microsoft.com/office/drawing/2014/main" id="{DF0D9955-3504-4825-ADC0-0E1F156AF575}"/>
               </a:ext>
             </a:extLst>
           </p:cNvPr>
           <p:cNvSpPr>
-            <a:spLocks xmlns:a="http://schemas.openxmlformats.org/drawingml/2006/main" noGrp="1"/>
+            <a:spLocks noGrp="1"/>
           </p:cNvSpPr>
           <p:nvPr/>
         </p:nvSpPr>
         <p:spPr>
-          <a:xfrm xmlns:a="http://schemas.openxmlformats.org/drawingml/2006/main">
+          <a:xfrm>
             <a:off x="609600" y="2171700"/>
             <a:ext cx="7239000" cy="952500"/>
           </a:xfrm>
-          <a:prstGeom xmlns:a="http://schemas.openxmlformats.org/drawingml/2006/main" prst="rect">
+          <a:prstGeom prst="rect">
             <a:avLst/>
           </a:prstGeom>
-          <a:noFill xmlns:a="http://schemas.openxmlformats.org/drawingml/2006/main"/>
-          <a:ln xmlns:a="http://schemas.openxmlformats.org/drawingml/2006/main" w="0">
+          <a:noFill/>
+          <a:ln w="0">
             <a:noFill/>
           </a:ln>
         </p:spPr>
         <p:txBody>
-          <a:bodyPr xmlns:a="http://schemas.openxmlformats.org/drawingml/2006/main"/>
-          <a:lstStyle xmlns:a="http://schemas.openxmlformats.org/drawingml/2006/main">
+          <a:bodyPr/>
+          <a:lstStyle>
             <a:defPPr>
               <a:defRPr sz="5400" b="1">
                 <a:solidFill>
@@ -4021,7 +3755,7 @@
               </a:defRPr>
             </a:lvl9pPr>
           </a:lstStyle>
-          <a:p xmlns:a="http://schemas.openxmlformats.org/drawingml/2006/main">
+          <a:p>
             <a:pPr>
               <a:defRPr sz="5400" b="1">
                 <a:solidFill>
@@ -4048,34 +3782,34 @@
       </p:sp>
       <p:sp>
         <p:nvSpPr>
-          <p:cNvPr id="4" name="">
-            <a:extLst xmlns:a="http://schemas.openxmlformats.org/drawingml/2006/main">
+          <p:cNvPr id="4" name="Rectangle 3">
+            <a:extLst>
               <a:ext uri="{FF2B5EF4-FFF2-40B4-BE49-F238E27FC236}">
                 <a16:creationId xmlns:a16="http://schemas.microsoft.com/office/drawing/2014/main" id="{99B6AB06-3F2E-49FE-BA89-FDE199DBAEF1}"/>
               </a:ext>
             </a:extLst>
           </p:cNvPr>
           <p:cNvSpPr>
-            <a:spLocks xmlns:a="http://schemas.openxmlformats.org/drawingml/2006/main" noGrp="1"/>
+            <a:spLocks noGrp="1"/>
           </p:cNvSpPr>
           <p:nvPr/>
         </p:nvSpPr>
         <p:spPr>
-          <a:xfrm xmlns:a="http://schemas.openxmlformats.org/drawingml/2006/main">
+          <a:xfrm>
             <a:off x="609600" y="3305175"/>
             <a:ext cx="7048500" cy="495300"/>
           </a:xfrm>
-          <a:prstGeom xmlns:a="http://schemas.openxmlformats.org/drawingml/2006/main" prst="rect">
+          <a:prstGeom prst="rect">
             <a:avLst/>
           </a:prstGeom>
-          <a:noFill xmlns:a="http://schemas.openxmlformats.org/drawingml/2006/main"/>
-          <a:ln xmlns:a="http://schemas.openxmlformats.org/drawingml/2006/main" w="0">
+          <a:noFill/>
+          <a:ln w="0">
             <a:noFill/>
           </a:ln>
         </p:spPr>
         <p:txBody>
-          <a:bodyPr xmlns:a="http://schemas.openxmlformats.org/drawingml/2006/main"/>
-          <a:lstStyle xmlns:a="http://schemas.openxmlformats.org/drawingml/2006/main">
+          <a:bodyPr/>
+          <a:lstStyle>
             <a:defPPr>
               <a:defRPr sz="2850" b="1">
                 <a:solidFill>
@@ -4177,7 +3911,7 @@
               </a:defRPr>
             </a:lvl9pPr>
           </a:lstStyle>
-          <a:p xmlns:a="http://schemas.openxmlformats.org/drawingml/2006/main">
+          <a:p>
             <a:pPr>
               <a:defRPr sz="2850" b="1">
                 <a:solidFill>
@@ -4204,34 +3938,34 @@
       </p:sp>
       <p:sp>
         <p:nvSpPr>
-          <p:cNvPr id="5" name="">
-            <a:extLst xmlns:a="http://schemas.openxmlformats.org/drawingml/2006/main">
+          <p:cNvPr id="5" name="Rectangle 4">
+            <a:extLst>
               <a:ext uri="{FF2B5EF4-FFF2-40B4-BE49-F238E27FC236}">
                 <a16:creationId xmlns:a16="http://schemas.microsoft.com/office/drawing/2014/main" id="{82A36B1A-CD04-4CB7-966E-8D77A4F564BC}"/>
               </a:ext>
             </a:extLst>
           </p:cNvPr>
           <p:cNvSpPr>
-            <a:spLocks xmlns:a="http://schemas.openxmlformats.org/drawingml/2006/main" noGrp="1"/>
+            <a:spLocks noGrp="1"/>
           </p:cNvSpPr>
           <p:nvPr/>
         </p:nvSpPr>
         <p:spPr>
-          <a:xfrm xmlns:a="http://schemas.openxmlformats.org/drawingml/2006/main">
+          <a:xfrm>
             <a:off x="609600" y="4162425"/>
             <a:ext cx="6667500" cy="381000"/>
           </a:xfrm>
-          <a:prstGeom xmlns:a="http://schemas.openxmlformats.org/drawingml/2006/main" prst="rect">
+          <a:prstGeom prst="rect">
             <a:avLst/>
           </a:prstGeom>
-          <a:noFill xmlns:a="http://schemas.openxmlformats.org/drawingml/2006/main"/>
-          <a:ln xmlns:a="http://schemas.openxmlformats.org/drawingml/2006/main" w="0">
+          <a:noFill/>
+          <a:ln w="0">
             <a:noFill/>
           </a:ln>
         </p:spPr>
         <p:txBody>
-          <a:bodyPr xmlns:a="http://schemas.openxmlformats.org/drawingml/2006/main"/>
-          <a:lstStyle xmlns:a="http://schemas.openxmlformats.org/drawingml/2006/main">
+          <a:bodyPr/>
+          <a:lstStyle>
             <a:defPPr>
               <a:defRPr sz="2175" b="0">
                 <a:solidFill>
@@ -4333,7 +4067,7 @@
               </a:defRPr>
             </a:lvl9pPr>
           </a:lstStyle>
-          <a:p xmlns:a="http://schemas.openxmlformats.org/drawingml/2006/main">
+          <a:p>
             <a:pPr>
               <a:defRPr sz="2175" b="0">
                 <a:solidFill>
@@ -4360,34 +4094,34 @@
       </p:sp>
       <p:sp>
         <p:nvSpPr>
-          <p:cNvPr id="6" name="">
-            <a:extLst xmlns:a="http://schemas.openxmlformats.org/drawingml/2006/main">
+          <p:cNvPr id="6" name="Rectangle 5">
+            <a:extLst>
               <a:ext uri="{FF2B5EF4-FFF2-40B4-BE49-F238E27FC236}">
                 <a16:creationId xmlns:a16="http://schemas.microsoft.com/office/drawing/2014/main" id="{7806064A-0B7D-40A2-8D4C-990E1CDCDD76}"/>
               </a:ext>
             </a:extLst>
           </p:cNvPr>
           <p:cNvSpPr>
-            <a:spLocks xmlns:a="http://schemas.openxmlformats.org/drawingml/2006/main" noGrp="1"/>
+            <a:spLocks noGrp="1"/>
           </p:cNvSpPr>
           <p:nvPr/>
         </p:nvSpPr>
         <p:spPr>
-          <a:xfrm xmlns:a="http://schemas.openxmlformats.org/drawingml/2006/main">
+          <a:xfrm>
             <a:off x="609600" y="4562475"/>
             <a:ext cx="6667500" cy="314325"/>
           </a:xfrm>
-          <a:prstGeom xmlns:a="http://schemas.openxmlformats.org/drawingml/2006/main" prst="rect">
+          <a:prstGeom prst="rect">
             <a:avLst/>
           </a:prstGeom>
-          <a:noFill xmlns:a="http://schemas.openxmlformats.org/drawingml/2006/main"/>
-          <a:ln xmlns:a="http://schemas.openxmlformats.org/drawingml/2006/main" w="0">
+          <a:noFill/>
+          <a:ln w="0">
             <a:noFill/>
           </a:ln>
         </p:spPr>
         <p:txBody>
-          <a:bodyPr xmlns:a="http://schemas.openxmlformats.org/drawingml/2006/main"/>
-          <a:lstStyle xmlns:a="http://schemas.openxmlformats.org/drawingml/2006/main">
+          <a:bodyPr/>
+          <a:lstStyle>
             <a:defPPr>
               <a:defRPr sz="1875" b="0">
                 <a:solidFill>
@@ -4489,7 +4223,7 @@
               </a:defRPr>
             </a:lvl9pPr>
           </a:lstStyle>
-          <a:p xmlns:a="http://schemas.openxmlformats.org/drawingml/2006/main">
+          <a:p>
             <a:pPr>
               <a:defRPr sz="1875" b="0">
                 <a:solidFill>
@@ -4516,34 +4250,34 @@
       </p:sp>
       <p:sp>
         <p:nvSpPr>
-          <p:cNvPr id="7" name="">
-            <a:extLst xmlns:a="http://schemas.openxmlformats.org/drawingml/2006/main">
+          <p:cNvPr id="7" name="Rectangle 6">
+            <a:extLst>
               <a:ext uri="{FF2B5EF4-FFF2-40B4-BE49-F238E27FC236}">
                 <a16:creationId xmlns:a16="http://schemas.microsoft.com/office/drawing/2014/main" id="{B2BC7248-F94B-4A11-979D-1EBD22964FC9}"/>
               </a:ext>
             </a:extLst>
           </p:cNvPr>
           <p:cNvSpPr>
-            <a:spLocks xmlns:a="http://schemas.openxmlformats.org/drawingml/2006/main" noGrp="1"/>
+            <a:spLocks noGrp="1"/>
           </p:cNvSpPr>
           <p:nvPr/>
         </p:nvSpPr>
         <p:spPr>
-          <a:xfrm xmlns:a="http://schemas.openxmlformats.org/drawingml/2006/main">
+          <a:xfrm>
             <a:off x="609600" y="5133975"/>
             <a:ext cx="6667500" cy="381000"/>
           </a:xfrm>
-          <a:prstGeom xmlns:a="http://schemas.openxmlformats.org/drawingml/2006/main" prst="rect">
+          <a:prstGeom prst="rect">
             <a:avLst/>
           </a:prstGeom>
-          <a:noFill xmlns:a="http://schemas.openxmlformats.org/drawingml/2006/main"/>
-          <a:ln xmlns:a="http://schemas.openxmlformats.org/drawingml/2006/main" w="0">
+          <a:noFill/>
+          <a:ln w="0">
             <a:noFill/>
           </a:ln>
         </p:spPr>
         <p:txBody>
-          <a:bodyPr xmlns:a="http://schemas.openxmlformats.org/drawingml/2006/main"/>
-          <a:lstStyle xmlns:a="http://schemas.openxmlformats.org/drawingml/2006/main">
+          <a:bodyPr/>
+          <a:lstStyle>
             <a:defPPr>
               <a:defRPr sz="2175" b="0">
                 <a:solidFill>
@@ -4645,7 +4379,7 @@
               </a:defRPr>
             </a:lvl9pPr>
           </a:lstStyle>
-          <a:p xmlns:a="http://schemas.openxmlformats.org/drawingml/2006/main">
+          <a:p>
             <a:pPr>
               <a:defRPr sz="2175" b="0">
                 <a:solidFill>
@@ -4672,34 +4406,34 @@
       </p:sp>
       <p:sp>
         <p:nvSpPr>
-          <p:cNvPr id="8" name="">
-            <a:extLst xmlns:a="http://schemas.openxmlformats.org/drawingml/2006/main">
+          <p:cNvPr id="8" name="Rectangle 7">
+            <a:extLst>
               <a:ext uri="{FF2B5EF4-FFF2-40B4-BE49-F238E27FC236}">
                 <a16:creationId xmlns:a16="http://schemas.microsoft.com/office/drawing/2014/main" id="{01F33899-9642-436D-8602-DEC8A20BBC9C}"/>
               </a:ext>
             </a:extLst>
           </p:cNvPr>
           <p:cNvSpPr>
-            <a:spLocks xmlns:a="http://schemas.openxmlformats.org/drawingml/2006/main" noGrp="1"/>
+            <a:spLocks noGrp="1"/>
           </p:cNvSpPr>
           <p:nvPr/>
         </p:nvSpPr>
         <p:spPr>
-          <a:xfrm xmlns:a="http://schemas.openxmlformats.org/drawingml/2006/main">
+          <a:xfrm>
             <a:off x="609600" y="5534025"/>
             <a:ext cx="6667500" cy="314325"/>
           </a:xfrm>
-          <a:prstGeom xmlns:a="http://schemas.openxmlformats.org/drawingml/2006/main" prst="rect">
+          <a:prstGeom prst="rect">
             <a:avLst/>
           </a:prstGeom>
-          <a:noFill xmlns:a="http://schemas.openxmlformats.org/drawingml/2006/main"/>
-          <a:ln xmlns:a="http://schemas.openxmlformats.org/drawingml/2006/main" w="0">
+          <a:noFill/>
+          <a:ln w="0">
             <a:noFill/>
           </a:ln>
         </p:spPr>
         <p:txBody>
-          <a:bodyPr xmlns:a="http://schemas.openxmlformats.org/drawingml/2006/main"/>
-          <a:lstStyle xmlns:a="http://schemas.openxmlformats.org/drawingml/2006/main">
+          <a:bodyPr/>
+          <a:lstStyle>
             <a:defPPr>
               <a:defRPr sz="1875" b="0">
                 <a:solidFill>
@@ -4801,7 +4535,7 @@
               </a:defRPr>
             </a:lvl9pPr>
           </a:lstStyle>
-          <a:p xmlns:a="http://schemas.openxmlformats.org/drawingml/2006/main">
+          <a:p>
             <a:pPr>
               <a:defRPr sz="1875" b="0">
                 <a:solidFill>
@@ -4828,62 +4562,62 @@
       </p:sp>
       <p:pic>
         <p:nvPicPr>
-          <p:cNvPr id="9" name="">
-            <a:extLst xmlns:a="http://schemas.openxmlformats.org/drawingml/2006/main">
+          <p:cNvPr id="9" name="Picture 8">
+            <a:extLst>
               <a:ext uri="{FF2B5EF4-FFF2-40B4-BE49-F238E27FC236}">
                 <a16:creationId xmlns:a16="http://schemas.microsoft.com/office/drawing/2014/main" id="{B57C27E6-BD8D-4C33-83A1-AB1AEA901F55}"/>
               </a:ext>
             </a:extLst>
           </p:cNvPr>
           <p:cNvPicPr>
-            <a:picLocks xmlns:a="http://schemas.openxmlformats.org/drawingml/2006/main" noChangeAspect="1"/>
+            <a:picLocks noChangeAspect="1"/>
           </p:cNvPicPr>
           <p:nvPr/>
         </p:nvPicPr>
         <p:blipFill>
-          <a:blip xmlns:r="http://schemas.openxmlformats.org/officeDocument/2006/relationships" xmlns:a="http://schemas.openxmlformats.org/drawingml/2006/main" r:embed="R66e7ca3db7954762"/>
-          <a:stretch xmlns:a="http://schemas.openxmlformats.org/drawingml/2006/main"/>
+          <a:blip r:embed="rId3"/>
+          <a:stretch/>
         </p:blipFill>
         <p:spPr>
-          <a:xfrm xmlns:a="http://schemas.openxmlformats.org/drawingml/2006/main">
+          <a:xfrm>
             <a:off x="8524875" y="2943225"/>
             <a:ext cx="2381250" cy="2381250"/>
           </a:xfrm>
-          <a:prstGeom xmlns:a="http://schemas.openxmlformats.org/drawingml/2006/main" prst="rect">
+          <a:prstGeom prst="rect">
             <a:avLst/>
           </a:prstGeom>
         </p:spPr>
       </p:pic>
       <p:sp>
         <p:nvSpPr>
-          <p:cNvPr id="10" name="">
-            <a:extLst xmlns:a="http://schemas.openxmlformats.org/drawingml/2006/main">
+          <p:cNvPr id="10" name="Rectangle 9">
+            <a:extLst>
               <a:ext uri="{FF2B5EF4-FFF2-40B4-BE49-F238E27FC236}">
                 <a16:creationId xmlns:a16="http://schemas.microsoft.com/office/drawing/2014/main" id="{3511DB42-AF8B-4847-84A5-4A312F1668BD}"/>
               </a:ext>
             </a:extLst>
           </p:cNvPr>
           <p:cNvSpPr>
-            <a:spLocks xmlns:a="http://schemas.openxmlformats.org/drawingml/2006/main" noGrp="1"/>
+            <a:spLocks noGrp="1"/>
           </p:cNvSpPr>
           <p:nvPr/>
         </p:nvSpPr>
         <p:spPr>
-          <a:xfrm xmlns:a="http://schemas.openxmlformats.org/drawingml/2006/main">
+          <a:xfrm>
             <a:off x="8010525" y="5476875"/>
             <a:ext cx="3619500" cy="400050"/>
           </a:xfrm>
-          <a:prstGeom xmlns:a="http://schemas.openxmlformats.org/drawingml/2006/main" prst="rect">
+          <a:prstGeom prst="rect">
             <a:avLst/>
           </a:prstGeom>
-          <a:noFill xmlns:a="http://schemas.openxmlformats.org/drawingml/2006/main"/>
-          <a:ln xmlns:a="http://schemas.openxmlformats.org/drawingml/2006/main" w="0">
+          <a:noFill/>
+          <a:ln w="0">
             <a:noFill/>
           </a:ln>
         </p:spPr>
         <p:txBody>
-          <a:bodyPr xmlns:a="http://schemas.openxmlformats.org/drawingml/2006/main"/>
-          <a:lstStyle xmlns:a="http://schemas.openxmlformats.org/drawingml/2006/main">
+          <a:bodyPr/>
+          <a:lstStyle>
             <a:defPPr>
               <a:defRPr sz="1950" b="1">
                 <a:solidFill>
@@ -4985,7 +4719,7 @@
               </a:defRPr>
             </a:lvl9pPr>
           </a:lstStyle>
-          <a:p xmlns:a="http://schemas.openxmlformats.org/drawingml/2006/main">
+          <a:p>
             <a:pPr>
               <a:defRPr sz="1950" b="1">
                 <a:solidFill>
@@ -5012,34 +4746,34 @@
       </p:sp>
       <p:sp>
         <p:nvSpPr>
-          <p:cNvPr id="11" name="">
-            <a:extLst xmlns:a="http://schemas.openxmlformats.org/drawingml/2006/main">
+          <p:cNvPr id="11" name="Rectangle 10">
+            <a:extLst>
               <a:ext uri="{FF2B5EF4-FFF2-40B4-BE49-F238E27FC236}">
                 <a16:creationId xmlns:a16="http://schemas.microsoft.com/office/drawing/2014/main" id="{B07CD4A1-6DE6-4216-A33C-AA9AC8075ABB}"/>
               </a:ext>
             </a:extLst>
           </p:cNvPr>
           <p:cNvSpPr>
-            <a:spLocks xmlns:a="http://schemas.openxmlformats.org/drawingml/2006/main" noGrp="1"/>
+            <a:spLocks noGrp="1"/>
           </p:cNvSpPr>
           <p:nvPr/>
         </p:nvSpPr>
         <p:spPr>
-          <a:xfrm xmlns:a="http://schemas.openxmlformats.org/drawingml/2006/main">
+          <a:xfrm>
             <a:off x="609600" y="6315075"/>
             <a:ext cx="10953750" cy="304800"/>
           </a:xfrm>
-          <a:prstGeom xmlns:a="http://schemas.openxmlformats.org/drawingml/2006/main" prst="rect">
+          <a:prstGeom prst="rect">
             <a:avLst/>
           </a:prstGeom>
-          <a:noFill xmlns:a="http://schemas.openxmlformats.org/drawingml/2006/main"/>
-          <a:ln xmlns:a="http://schemas.openxmlformats.org/drawingml/2006/main" w="0">
+          <a:noFill/>
+          <a:ln w="0">
             <a:noFill/>
           </a:ln>
         </p:spPr>
         <p:txBody>
-          <a:bodyPr xmlns:a="http://schemas.openxmlformats.org/drawingml/2006/main"/>
-          <a:lstStyle xmlns:a="http://schemas.openxmlformats.org/drawingml/2006/main">
+          <a:bodyPr/>
+          <a:lstStyle>
             <a:defPPr>
               <a:defRPr sz="1575" b="0">
                 <a:solidFill>
@@ -5141,7 +4875,7 @@
               </a:defRPr>
             </a:lvl9pPr>
           </a:lstStyle>
-          <a:p xmlns:a="http://schemas.openxmlformats.org/drawingml/2006/main">
+          <a:p>
             <a:pPr>
               <a:defRPr sz="1575" b="0">
                 <a:solidFill>
@@ -5173,17 +4907,21 @@
       </p:ext>
     </p:extLst>
   </p:cSld>
+  <p:clrMapOvr>
+    <a:masterClrMapping/>
+  </p:clrMapOvr>
 </p:sld>
 </file>
 
 <file path=ppt/slides/slide2.xml><?xml version="1.0" encoding="utf-8"?>
-<p:sld xmlns:p="http://schemas.openxmlformats.org/presentationml/2006/main">
+<p:sld xmlns:a="http://schemas.openxmlformats.org/drawingml/2006/main" xmlns:r="http://schemas.openxmlformats.org/officeDocument/2006/relationships" xmlns:p="http://schemas.openxmlformats.org/presentationml/2006/main">
   <p:cSld>
     <p:bg>
       <p:bgPr>
-        <a:solidFill xmlns:a="http://schemas.openxmlformats.org/drawingml/2006/main">
+        <a:solidFill>
           <a:srgbClr val="FFFFFF"/>
         </a:solidFill>
+        <a:effectLst/>
       </p:bgPr>
     </p:bg>
     <p:spTree>
@@ -5193,38 +4931,43 @@
         <p:nvPr/>
       </p:nvGrpSpPr>
       <p:grpSpPr>
-        <a:xfrm xmlns:a="http://schemas.openxmlformats.org/drawingml/2006/main"/>
+        <a:xfrm>
+          <a:off x="0" y="0"/>
+          <a:ext cx="0" cy="0"/>
+          <a:chOff x="0" y="0"/>
+          <a:chExt cx="0" cy="0"/>
+        </a:xfrm>
       </p:grpSpPr>
       <p:sp>
         <p:nvSpPr>
-          <p:cNvPr id="15" name="">
-            <a:extLst xmlns:a="http://schemas.openxmlformats.org/drawingml/2006/main">
+          <p:cNvPr id="15" name="Rectangle 14">
+            <a:extLst>
               <a:ext uri="{FF2B5EF4-FFF2-40B4-BE49-F238E27FC236}">
                 <a16:creationId xmlns:a16="http://schemas.microsoft.com/office/drawing/2014/main" id="{47CBBAD2-DC39-43E9-A0ED-C94131DAE0F7}"/>
               </a:ext>
             </a:extLst>
           </p:cNvPr>
           <p:cNvSpPr>
-            <a:spLocks xmlns:a="http://schemas.openxmlformats.org/drawingml/2006/main" noGrp="1"/>
+            <a:spLocks noGrp="1"/>
           </p:cNvSpPr>
           <p:nvPr/>
         </p:nvSpPr>
         <p:spPr>
-          <a:xfrm xmlns:a="http://schemas.openxmlformats.org/drawingml/2006/main">
+          <a:xfrm>
             <a:off x="609600" y="428625"/>
             <a:ext cx="10953750" cy="666750"/>
           </a:xfrm>
-          <a:prstGeom xmlns:a="http://schemas.openxmlformats.org/drawingml/2006/main" prst="rect">
+          <a:prstGeom prst="rect">
             <a:avLst/>
           </a:prstGeom>
-          <a:noFill xmlns:a="http://schemas.openxmlformats.org/drawingml/2006/main"/>
-          <a:ln xmlns:a="http://schemas.openxmlformats.org/drawingml/2006/main" w="0">
+          <a:noFill/>
+          <a:ln w="0">
             <a:noFill/>
           </a:ln>
         </p:spPr>
         <p:txBody>
-          <a:bodyPr xmlns:a="http://schemas.openxmlformats.org/drawingml/2006/main"/>
-          <a:lstStyle xmlns:a="http://schemas.openxmlformats.org/drawingml/2006/main">
+          <a:bodyPr/>
+          <a:lstStyle>
             <a:defPPr>
               <a:defRPr sz="3450" b="1">
                 <a:solidFill>
@@ -5326,7 +5069,7 @@
               </a:defRPr>
             </a:lvl9pPr>
           </a:lstStyle>
-          <a:p xmlns:a="http://schemas.openxmlformats.org/drawingml/2006/main">
+          <a:p>
             <a:pPr>
               <a:defRPr sz="3450" b="1">
                 <a:solidFill>
@@ -5353,34 +5096,34 @@
       </p:sp>
       <p:sp>
         <p:nvSpPr>
-          <p:cNvPr id="2" name="">
-            <a:extLst xmlns:a="http://schemas.openxmlformats.org/drawingml/2006/main">
+          <p:cNvPr id="2" name="Rectangle 1">
+            <a:extLst>
               <a:ext uri="{FF2B5EF4-FFF2-40B4-BE49-F238E27FC236}">
                 <a16:creationId xmlns:a16="http://schemas.microsoft.com/office/drawing/2014/main" id="{82E3B6D6-FEB6-48CB-9A96-62B32AF70191}"/>
               </a:ext>
             </a:extLst>
           </p:cNvPr>
           <p:cNvSpPr>
-            <a:spLocks xmlns:a="http://schemas.openxmlformats.org/drawingml/2006/main" noGrp="1"/>
+            <a:spLocks noGrp="1"/>
           </p:cNvSpPr>
           <p:nvPr/>
         </p:nvSpPr>
         <p:spPr>
-          <a:xfrm xmlns:a="http://schemas.openxmlformats.org/drawingml/2006/main">
+          <a:xfrm>
             <a:off x="609600" y="6400800"/>
             <a:ext cx="9525000" cy="238125"/>
           </a:xfrm>
-          <a:prstGeom xmlns:a="http://schemas.openxmlformats.org/drawingml/2006/main" prst="rect">
+          <a:prstGeom prst="rect">
             <a:avLst/>
           </a:prstGeom>
-          <a:noFill xmlns:a="http://schemas.openxmlformats.org/drawingml/2006/main"/>
-          <a:ln xmlns:a="http://schemas.openxmlformats.org/drawingml/2006/main" w="0">
+          <a:noFill/>
+          <a:ln w="0">
             <a:noFill/>
           </a:ln>
         </p:spPr>
         <p:txBody>
-          <a:bodyPr xmlns:a="http://schemas.openxmlformats.org/drawingml/2006/main"/>
-          <a:lstStyle xmlns:a="http://schemas.openxmlformats.org/drawingml/2006/main">
+          <a:bodyPr/>
+          <a:lstStyle>
             <a:defPPr>
               <a:defRPr sz="1275" b="0">
                 <a:solidFill>
@@ -5482,7 +5225,7 @@
               </a:defRPr>
             </a:lvl9pPr>
           </a:lstStyle>
-          <a:p xmlns:a="http://schemas.openxmlformats.org/drawingml/2006/main">
+          <a:p>
             <a:pPr>
               <a:defRPr sz="1275" b="0">
                 <a:solidFill>
@@ -5509,34 +5252,34 @@
       </p:sp>
       <p:sp>
         <p:nvSpPr>
-          <p:cNvPr id="3" name="">
-            <a:extLst xmlns:a="http://schemas.openxmlformats.org/drawingml/2006/main">
+          <p:cNvPr id="3" name="Rectangle 2">
+            <a:extLst>
               <a:ext uri="{FF2B5EF4-FFF2-40B4-BE49-F238E27FC236}">
                 <a16:creationId xmlns:a16="http://schemas.microsoft.com/office/drawing/2014/main" id="{4811E24E-92AE-4372-9B72-32167B6D39A8}"/>
               </a:ext>
             </a:extLst>
           </p:cNvPr>
           <p:cNvSpPr>
-            <a:spLocks xmlns:a="http://schemas.openxmlformats.org/drawingml/2006/main" noGrp="1"/>
+            <a:spLocks noGrp="1"/>
           </p:cNvSpPr>
           <p:nvPr/>
         </p:nvSpPr>
         <p:spPr>
-          <a:xfrm xmlns:a="http://schemas.openxmlformats.org/drawingml/2006/main">
+          <a:xfrm>
             <a:off x="11191875" y="6400800"/>
             <a:ext cx="428625" cy="238125"/>
           </a:xfrm>
-          <a:prstGeom xmlns:a="http://schemas.openxmlformats.org/drawingml/2006/main" prst="rect">
+          <a:prstGeom prst="rect">
             <a:avLst/>
           </a:prstGeom>
-          <a:noFill xmlns:a="http://schemas.openxmlformats.org/drawingml/2006/main"/>
-          <a:ln xmlns:a="http://schemas.openxmlformats.org/drawingml/2006/main" w="0">
+          <a:noFill/>
+          <a:ln w="0">
             <a:noFill/>
           </a:ln>
         </p:spPr>
         <p:txBody>
-          <a:bodyPr xmlns:a="http://schemas.openxmlformats.org/drawingml/2006/main"/>
-          <a:lstStyle xmlns:a="http://schemas.openxmlformats.org/drawingml/2006/main">
+          <a:bodyPr/>
+          <a:lstStyle>
             <a:defPPr>
               <a:defRPr sz="1275" b="0">
                 <a:solidFill>
@@ -5638,7 +5381,7 @@
               </a:defRPr>
             </a:lvl9pPr>
           </a:lstStyle>
-          <a:p xmlns:a="http://schemas.openxmlformats.org/drawingml/2006/main">
+          <a:p>
             <a:pPr>
               <a:defRPr sz="1275" b="0">
                 <a:solidFill>
@@ -5665,34 +5408,34 @@
       </p:sp>
       <p:sp>
         <p:nvSpPr>
-          <p:cNvPr id="4" name="">
-            <a:extLst xmlns:a="http://schemas.openxmlformats.org/drawingml/2006/main">
+          <p:cNvPr id="4" name="Rectangle 3">
+            <a:extLst>
               <a:ext uri="{FF2B5EF4-FFF2-40B4-BE49-F238E27FC236}">
                 <a16:creationId xmlns:a16="http://schemas.microsoft.com/office/drawing/2014/main" id="{DBA11A65-F1CC-444F-8F37-EA1F7319C5B4}"/>
               </a:ext>
             </a:extLst>
           </p:cNvPr>
           <p:cNvSpPr>
-            <a:spLocks xmlns:a="http://schemas.openxmlformats.org/drawingml/2006/main" noGrp="1"/>
+            <a:spLocks noGrp="1"/>
           </p:cNvSpPr>
           <p:nvPr/>
         </p:nvSpPr>
         <p:spPr>
-          <a:xfrm xmlns:a="http://schemas.openxmlformats.org/drawingml/2006/main">
+          <a:xfrm>
             <a:off x="609600" y="1476375"/>
             <a:ext cx="5238750" cy="400050"/>
           </a:xfrm>
-          <a:prstGeom xmlns:a="http://schemas.openxmlformats.org/drawingml/2006/main" prst="rect">
+          <a:prstGeom prst="rect">
             <a:avLst/>
           </a:prstGeom>
-          <a:noFill xmlns:a="http://schemas.openxmlformats.org/drawingml/2006/main"/>
-          <a:ln xmlns:a="http://schemas.openxmlformats.org/drawingml/2006/main" w="0">
+          <a:noFill/>
+          <a:ln w="0">
             <a:noFill/>
           </a:ln>
         </p:spPr>
         <p:txBody>
-          <a:bodyPr xmlns:a="http://schemas.openxmlformats.org/drawingml/2006/main"/>
-          <a:lstStyle xmlns:a="http://schemas.openxmlformats.org/drawingml/2006/main">
+          <a:bodyPr/>
+          <a:lstStyle>
             <a:defPPr>
               <a:defRPr sz="2400" b="1">
                 <a:solidFill>
@@ -5794,7 +5537,7 @@
               </a:defRPr>
             </a:lvl9pPr>
           </a:lstStyle>
-          <a:p xmlns:a="http://schemas.openxmlformats.org/drawingml/2006/main">
+          <a:p>
             <a:pPr>
               <a:defRPr sz="2400" b="1">
                 <a:solidFill>
@@ -5821,34 +5564,34 @@
       </p:sp>
       <p:sp>
         <p:nvSpPr>
-          <p:cNvPr id="5" name="">
-            <a:extLst xmlns:a="http://schemas.openxmlformats.org/drawingml/2006/main">
+          <p:cNvPr id="5" name="Rectangle 4">
+            <a:extLst>
               <a:ext uri="{FF2B5EF4-FFF2-40B4-BE49-F238E27FC236}">
                 <a16:creationId xmlns:a16="http://schemas.microsoft.com/office/drawing/2014/main" id="{C932B52A-A4B0-4C48-9E74-F21BB4E530A8}"/>
               </a:ext>
             </a:extLst>
           </p:cNvPr>
           <p:cNvSpPr>
-            <a:spLocks xmlns:a="http://schemas.openxmlformats.org/drawingml/2006/main" noGrp="1"/>
+            <a:spLocks noGrp="1"/>
           </p:cNvSpPr>
           <p:nvPr/>
         </p:nvSpPr>
         <p:spPr>
-          <a:xfrm xmlns:a="http://schemas.openxmlformats.org/drawingml/2006/main">
+          <a:xfrm>
             <a:off x="609600" y="2038350"/>
             <a:ext cx="5238750" cy="361950"/>
           </a:xfrm>
-          <a:prstGeom xmlns:a="http://schemas.openxmlformats.org/drawingml/2006/main" prst="rect">
+          <a:prstGeom prst="rect">
             <a:avLst/>
           </a:prstGeom>
-          <a:noFill xmlns:a="http://schemas.openxmlformats.org/drawingml/2006/main"/>
-          <a:ln xmlns:a="http://schemas.openxmlformats.org/drawingml/2006/main" w="0">
+          <a:noFill/>
+          <a:ln w="0">
             <a:noFill/>
           </a:ln>
         </p:spPr>
         <p:txBody>
-          <a:bodyPr xmlns:a="http://schemas.openxmlformats.org/drawingml/2006/main"/>
-          <a:lstStyle xmlns:a="http://schemas.openxmlformats.org/drawingml/2006/main">
+          <a:bodyPr/>
+          <a:lstStyle>
             <a:defPPr>
               <a:defRPr sz="2100" b="0">
                 <a:solidFill>
@@ -5950,7 +5693,7 @@
               </a:defRPr>
             </a:lvl9pPr>
           </a:lstStyle>
-          <a:p xmlns:a="http://schemas.openxmlformats.org/drawingml/2006/main">
+          <a:p>
             <a:pPr>
               <a:defRPr sz="2100" b="0">
                 <a:solidFill>
@@ -5977,34 +5720,34 @@
       </p:sp>
       <p:sp>
         <p:nvSpPr>
-          <p:cNvPr id="6" name="">
-            <a:extLst xmlns:a="http://schemas.openxmlformats.org/drawingml/2006/main">
+          <p:cNvPr id="6" name="Rectangle 5">
+            <a:extLst>
               <a:ext uri="{FF2B5EF4-FFF2-40B4-BE49-F238E27FC236}">
                 <a16:creationId xmlns:a16="http://schemas.microsoft.com/office/drawing/2014/main" id="{75FA3FAC-4029-4AA7-BB84-8E99203DCC2C}"/>
               </a:ext>
             </a:extLst>
           </p:cNvPr>
           <p:cNvSpPr>
-            <a:spLocks xmlns:a="http://schemas.openxmlformats.org/drawingml/2006/main" noGrp="1"/>
+            <a:spLocks noGrp="1"/>
           </p:cNvSpPr>
           <p:nvPr/>
         </p:nvSpPr>
         <p:spPr>
-          <a:xfrm xmlns:a="http://schemas.openxmlformats.org/drawingml/2006/main">
+          <a:xfrm>
             <a:off x="609600" y="2476500"/>
             <a:ext cx="5238750" cy="361950"/>
           </a:xfrm>
-          <a:prstGeom xmlns:a="http://schemas.openxmlformats.org/drawingml/2006/main" prst="rect">
+          <a:prstGeom prst="rect">
             <a:avLst/>
           </a:prstGeom>
-          <a:noFill xmlns:a="http://schemas.openxmlformats.org/drawingml/2006/main"/>
-          <a:ln xmlns:a="http://schemas.openxmlformats.org/drawingml/2006/main" w="0">
+          <a:noFill/>
+          <a:ln w="0">
             <a:noFill/>
           </a:ln>
         </p:spPr>
         <p:txBody>
-          <a:bodyPr xmlns:a="http://schemas.openxmlformats.org/drawingml/2006/main"/>
-          <a:lstStyle xmlns:a="http://schemas.openxmlformats.org/drawingml/2006/main">
+          <a:bodyPr/>
+          <a:lstStyle>
             <a:defPPr>
               <a:defRPr sz="2100" b="0">
                 <a:solidFill>
@@ -6106,7 +5849,7 @@
               </a:defRPr>
             </a:lvl9pPr>
           </a:lstStyle>
-          <a:p xmlns:a="http://schemas.openxmlformats.org/drawingml/2006/main">
+          <a:p>
             <a:pPr>
               <a:defRPr sz="2100" b="0">
                 <a:solidFill>
@@ -6133,34 +5876,34 @@
       </p:sp>
       <p:sp>
         <p:nvSpPr>
-          <p:cNvPr id="7" name="">
-            <a:extLst xmlns:a="http://schemas.openxmlformats.org/drawingml/2006/main">
+          <p:cNvPr id="7" name="Rectangle 6">
+            <a:extLst>
               <a:ext uri="{FF2B5EF4-FFF2-40B4-BE49-F238E27FC236}">
                 <a16:creationId xmlns:a16="http://schemas.microsoft.com/office/drawing/2014/main" id="{9C1FFA38-ADA1-45CD-8EC7-4C55087CBD7D}"/>
               </a:ext>
             </a:extLst>
           </p:cNvPr>
           <p:cNvSpPr>
-            <a:spLocks xmlns:a="http://schemas.openxmlformats.org/drawingml/2006/main" noGrp="1"/>
+            <a:spLocks noGrp="1"/>
           </p:cNvSpPr>
           <p:nvPr/>
         </p:nvSpPr>
         <p:spPr>
-          <a:xfrm xmlns:a="http://schemas.openxmlformats.org/drawingml/2006/main">
+          <a:xfrm>
             <a:off x="609600" y="2914650"/>
             <a:ext cx="5429250" cy="361950"/>
           </a:xfrm>
-          <a:prstGeom xmlns:a="http://schemas.openxmlformats.org/drawingml/2006/main" prst="rect">
+          <a:prstGeom prst="rect">
             <a:avLst/>
           </a:prstGeom>
-          <a:noFill xmlns:a="http://schemas.openxmlformats.org/drawingml/2006/main"/>
-          <a:ln xmlns:a="http://schemas.openxmlformats.org/drawingml/2006/main" w="0">
+          <a:noFill/>
+          <a:ln w="0">
             <a:noFill/>
           </a:ln>
         </p:spPr>
         <p:txBody>
-          <a:bodyPr xmlns:a="http://schemas.openxmlformats.org/drawingml/2006/main"/>
-          <a:lstStyle xmlns:a="http://schemas.openxmlformats.org/drawingml/2006/main">
+          <a:bodyPr/>
+          <a:lstStyle>
             <a:defPPr>
               <a:defRPr sz="2100" b="0">
                 <a:solidFill>
@@ -6262,7 +6005,7 @@
               </a:defRPr>
             </a:lvl9pPr>
           </a:lstStyle>
-          <a:p xmlns:a="http://schemas.openxmlformats.org/drawingml/2006/main">
+          <a:p>
             <a:pPr>
               <a:defRPr sz="2100" b="0">
                 <a:solidFill>
@@ -6289,34 +6032,34 @@
       </p:sp>
       <p:sp>
         <p:nvSpPr>
-          <p:cNvPr id="8" name="">
-            <a:extLst xmlns:a="http://schemas.openxmlformats.org/drawingml/2006/main">
+          <p:cNvPr id="8" name="Rectangle 7">
+            <a:extLst>
               <a:ext uri="{FF2B5EF4-FFF2-40B4-BE49-F238E27FC236}">
                 <a16:creationId xmlns:a16="http://schemas.microsoft.com/office/drawing/2014/main" id="{19B6D953-D15C-4E22-B150-8E85BA26B603}"/>
               </a:ext>
             </a:extLst>
           </p:cNvPr>
           <p:cNvSpPr>
-            <a:spLocks xmlns:a="http://schemas.openxmlformats.org/drawingml/2006/main" noGrp="1"/>
+            <a:spLocks noGrp="1"/>
           </p:cNvSpPr>
           <p:nvPr/>
         </p:nvSpPr>
         <p:spPr>
-          <a:xfrm xmlns:a="http://schemas.openxmlformats.org/drawingml/2006/main">
+          <a:xfrm>
             <a:off x="609600" y="3419475"/>
             <a:ext cx="5238750" cy="666750"/>
           </a:xfrm>
-          <a:prstGeom xmlns:a="http://schemas.openxmlformats.org/drawingml/2006/main" prst="rect">
+          <a:prstGeom prst="rect">
             <a:avLst/>
           </a:prstGeom>
-          <a:noFill xmlns:a="http://schemas.openxmlformats.org/drawingml/2006/main"/>
-          <a:ln xmlns:a="http://schemas.openxmlformats.org/drawingml/2006/main" w="0">
+          <a:noFill/>
+          <a:ln w="0">
             <a:noFill/>
           </a:ln>
         </p:spPr>
         <p:txBody>
-          <a:bodyPr xmlns:a="http://schemas.openxmlformats.org/drawingml/2006/main"/>
-          <a:lstStyle xmlns:a="http://schemas.openxmlformats.org/drawingml/2006/main">
+          <a:bodyPr/>
+          <a:lstStyle>
             <a:defPPr>
               <a:defRPr sz="1950" b="0">
                 <a:solidFill>
@@ -6418,7 +6161,7 @@
               </a:defRPr>
             </a:lvl9pPr>
           </a:lstStyle>
-          <a:p xmlns:a="http://schemas.openxmlformats.org/drawingml/2006/main">
+          <a:p>
             <a:pPr>
               <a:defRPr sz="1950" b="0">
                 <a:solidFill>
@@ -6445,34 +6188,34 @@
       </p:sp>
       <p:sp>
         <p:nvSpPr>
-          <p:cNvPr id="9" name="">
-            <a:extLst xmlns:a="http://schemas.openxmlformats.org/drawingml/2006/main">
+          <p:cNvPr id="9" name="Rectangle 8">
+            <a:extLst>
               <a:ext uri="{FF2B5EF4-FFF2-40B4-BE49-F238E27FC236}">
                 <a16:creationId xmlns:a16="http://schemas.microsoft.com/office/drawing/2014/main" id="{B9EB874C-106F-4464-A59F-89A5CFCB0A63}"/>
               </a:ext>
             </a:extLst>
           </p:cNvPr>
           <p:cNvSpPr>
-            <a:spLocks xmlns:a="http://schemas.openxmlformats.org/drawingml/2006/main" noGrp="1"/>
+            <a:spLocks noGrp="1"/>
           </p:cNvSpPr>
           <p:nvPr/>
         </p:nvSpPr>
         <p:spPr>
-          <a:xfrm xmlns:a="http://schemas.openxmlformats.org/drawingml/2006/main">
+          <a:xfrm>
             <a:off x="609600" y="4248150"/>
             <a:ext cx="5334000" cy="742950"/>
           </a:xfrm>
-          <a:prstGeom xmlns:a="http://schemas.openxmlformats.org/drawingml/2006/main" prst="rect">
+          <a:prstGeom prst="rect">
             <a:avLst/>
           </a:prstGeom>
-          <a:noFill xmlns:a="http://schemas.openxmlformats.org/drawingml/2006/main"/>
-          <a:ln xmlns:a="http://schemas.openxmlformats.org/drawingml/2006/main" w="0">
+          <a:noFill/>
+          <a:ln w="0">
             <a:noFill/>
           </a:ln>
         </p:spPr>
         <p:txBody>
-          <a:bodyPr xmlns:a="http://schemas.openxmlformats.org/drawingml/2006/main"/>
-          <a:lstStyle xmlns:a="http://schemas.openxmlformats.org/drawingml/2006/main">
+          <a:bodyPr/>
+          <a:lstStyle>
             <a:defPPr>
               <a:defRPr sz="2100" b="1">
                 <a:solidFill>
@@ -6574,7 +6317,7 @@
               </a:defRPr>
             </a:lvl9pPr>
           </a:lstStyle>
-          <a:p xmlns:a="http://schemas.openxmlformats.org/drawingml/2006/main">
+          <a:p>
             <a:pPr>
               <a:defRPr sz="2100" b="1">
                 <a:solidFill>
@@ -6597,7 +6340,7 @@
               <a:t>Erfüllt ab: Anzahl der Übungswochen</a:t>
             </a:r>
           </a:p>
-          <a:p xmlns:a="http://schemas.openxmlformats.org/drawingml/2006/main">
+          <a:p>
             <a:pPr>
               <a:defRPr sz="2100" b="1">
                 <a:solidFill>
@@ -6624,34 +6367,34 @@
       </p:sp>
       <p:sp>
         <p:nvSpPr>
-          <p:cNvPr id="10" name="">
-            <a:extLst xmlns:a="http://schemas.openxmlformats.org/drawingml/2006/main">
+          <p:cNvPr id="10" name="Rectangle 9">
+            <a:extLst>
               <a:ext uri="{FF2B5EF4-FFF2-40B4-BE49-F238E27FC236}">
                 <a16:creationId xmlns:a16="http://schemas.microsoft.com/office/drawing/2014/main" id="{46015E44-A133-4B68-ACAB-5226461C2689}"/>
               </a:ext>
             </a:extLst>
           </p:cNvPr>
           <p:cNvSpPr>
-            <a:spLocks xmlns:a="http://schemas.openxmlformats.org/drawingml/2006/main" noGrp="1"/>
+            <a:spLocks noGrp="1"/>
           </p:cNvSpPr>
           <p:nvPr/>
         </p:nvSpPr>
         <p:spPr>
-          <a:xfrm xmlns:a="http://schemas.openxmlformats.org/drawingml/2006/main">
+          <a:xfrm>
             <a:off x="6496050" y="1476375"/>
             <a:ext cx="5048250" cy="400050"/>
           </a:xfrm>
-          <a:prstGeom xmlns:a="http://schemas.openxmlformats.org/drawingml/2006/main" prst="rect">
+          <a:prstGeom prst="rect">
             <a:avLst/>
           </a:prstGeom>
-          <a:noFill xmlns:a="http://schemas.openxmlformats.org/drawingml/2006/main"/>
-          <a:ln xmlns:a="http://schemas.openxmlformats.org/drawingml/2006/main" w="0">
+          <a:noFill/>
+          <a:ln w="0">
             <a:noFill/>
           </a:ln>
         </p:spPr>
         <p:txBody>
-          <a:bodyPr xmlns:a="http://schemas.openxmlformats.org/drawingml/2006/main"/>
-          <a:lstStyle xmlns:a="http://schemas.openxmlformats.org/drawingml/2006/main">
+          <a:bodyPr/>
+          <a:lstStyle>
             <a:defPPr>
               <a:defRPr sz="2400" b="1">
                 <a:solidFill>
@@ -6753,7 +6496,7 @@
               </a:defRPr>
             </a:lvl9pPr>
           </a:lstStyle>
-          <a:p xmlns:a="http://schemas.openxmlformats.org/drawingml/2006/main">
+          <a:p>
             <a:pPr>
               <a:defRPr sz="2400" b="1">
                 <a:solidFill>
@@ -6780,34 +6523,34 @@
       </p:sp>
       <p:sp>
         <p:nvSpPr>
-          <p:cNvPr id="11" name="">
-            <a:extLst xmlns:a="http://schemas.openxmlformats.org/drawingml/2006/main">
+          <p:cNvPr id="11" name="Rectangle 10">
+            <a:extLst>
               <a:ext uri="{FF2B5EF4-FFF2-40B4-BE49-F238E27FC236}">
                 <a16:creationId xmlns:a16="http://schemas.microsoft.com/office/drawing/2014/main" id="{903B500A-205E-4649-A4B2-322E07C04166}"/>
               </a:ext>
             </a:extLst>
           </p:cNvPr>
           <p:cNvSpPr>
-            <a:spLocks xmlns:a="http://schemas.openxmlformats.org/drawingml/2006/main" noGrp="1"/>
+            <a:spLocks noGrp="1"/>
           </p:cNvSpPr>
           <p:nvPr/>
         </p:nvSpPr>
         <p:spPr>
-          <a:xfrm xmlns:a="http://schemas.openxmlformats.org/drawingml/2006/main">
+          <a:xfrm>
             <a:off x="6496050" y="2038350"/>
             <a:ext cx="5048250" cy="809625"/>
           </a:xfrm>
-          <a:prstGeom xmlns:a="http://schemas.openxmlformats.org/drawingml/2006/main" prst="rect">
+          <a:prstGeom prst="rect">
             <a:avLst/>
           </a:prstGeom>
-          <a:noFill xmlns:a="http://schemas.openxmlformats.org/drawingml/2006/main"/>
-          <a:ln xmlns:a="http://schemas.openxmlformats.org/drawingml/2006/main" w="0">
+          <a:noFill/>
+          <a:ln w="0">
             <a:noFill/>
           </a:ln>
         </p:spPr>
         <p:txBody>
-          <a:bodyPr xmlns:a="http://schemas.openxmlformats.org/drawingml/2006/main"/>
-          <a:lstStyle xmlns:a="http://schemas.openxmlformats.org/drawingml/2006/main">
+          <a:bodyPr/>
+          <a:lstStyle>
             <a:defPPr>
               <a:defRPr sz="2100" b="0">
                 <a:solidFill>
@@ -6909,7 +6652,7 @@
               </a:defRPr>
             </a:lvl9pPr>
           </a:lstStyle>
-          <a:p xmlns:a="http://schemas.openxmlformats.org/drawingml/2006/main">
+          <a:p>
             <a:pPr>
               <a:defRPr sz="2100" b="0">
                 <a:solidFill>
@@ -6932,7 +6675,7 @@
               <a:t>Ab der zweiten Woche:</a:t>
             </a:r>
           </a:p>
-          <a:p xmlns:a="http://schemas.openxmlformats.org/drawingml/2006/main">
+          <a:p>
             <a:pPr>
               <a:defRPr sz="2100" b="0">
                 <a:solidFill>
@@ -6959,34 +6702,34 @@
       </p:sp>
       <p:sp>
         <p:nvSpPr>
-          <p:cNvPr id="12" name="">
-            <a:extLst xmlns:a="http://schemas.openxmlformats.org/drawingml/2006/main">
+          <p:cNvPr id="12" name="Rectangle 11">
+            <a:extLst>
               <a:ext uri="{FF2B5EF4-FFF2-40B4-BE49-F238E27FC236}">
                 <a16:creationId xmlns:a16="http://schemas.microsoft.com/office/drawing/2014/main" id="{55000745-1F78-4A0E-9D3C-FA196E2F0A51}"/>
               </a:ext>
             </a:extLst>
           </p:cNvPr>
           <p:cNvSpPr>
-            <a:spLocks xmlns:a="http://schemas.openxmlformats.org/drawingml/2006/main" noGrp="1"/>
+            <a:spLocks noGrp="1"/>
           </p:cNvSpPr>
           <p:nvPr/>
         </p:nvSpPr>
         <p:spPr>
-          <a:xfrm xmlns:a="http://schemas.openxmlformats.org/drawingml/2006/main">
+          <a:xfrm>
             <a:off x="6496050" y="3133725"/>
             <a:ext cx="5048250" cy="1190625"/>
           </a:xfrm>
-          <a:prstGeom xmlns:a="http://schemas.openxmlformats.org/drawingml/2006/main" prst="rect">
+          <a:prstGeom prst="rect">
             <a:avLst/>
           </a:prstGeom>
-          <a:noFill xmlns:a="http://schemas.openxmlformats.org/drawingml/2006/main"/>
-          <a:ln xmlns:a="http://schemas.openxmlformats.org/drawingml/2006/main" w="0">
+          <a:noFill/>
+          <a:ln w="0">
             <a:noFill/>
           </a:ln>
         </p:spPr>
         <p:txBody>
-          <a:bodyPr xmlns:a="http://schemas.openxmlformats.org/drawingml/2006/main"/>
-          <a:lstStyle xmlns:a="http://schemas.openxmlformats.org/drawingml/2006/main">
+          <a:bodyPr/>
+          <a:lstStyle>
             <a:defPPr>
               <a:defRPr sz="2100" b="1">
                 <a:solidFill>
@@ -7088,7 +6831,7 @@
               </a:defRPr>
             </a:lvl9pPr>
           </a:lstStyle>
-          <a:p xmlns:a="http://schemas.openxmlformats.org/drawingml/2006/main">
+          <a:p>
             <a:pPr>
               <a:defRPr sz="2100" b="1">
                 <a:solidFill>
@@ -7111,7 +6854,7 @@
               <a:t>Erfüllt mit mindestens 25 %</a:t>
             </a:r>
           </a:p>
-          <a:p xmlns:a="http://schemas.openxmlformats.org/drawingml/2006/main">
+          <a:p>
             <a:pPr>
               <a:defRPr sz="2100" b="1">
                 <a:solidFill>
@@ -7134,7 +6877,7 @@
               <a:t>der insgesamt möglichen Quizpunkte</a:t>
             </a:r>
           </a:p>
-          <a:p xmlns:a="http://schemas.openxmlformats.org/drawingml/2006/main">
+          <a:p>
             <a:pPr>
               <a:defRPr sz="2100" b="1">
                 <a:solidFill>
@@ -7161,34 +6904,34 @@
       </p:sp>
       <p:sp>
         <p:nvSpPr>
-          <p:cNvPr id="13" name="">
-            <a:extLst xmlns:a="http://schemas.openxmlformats.org/drawingml/2006/main">
+          <p:cNvPr id="13" name="Rectangle 12">
+            <a:extLst>
               <a:ext uri="{FF2B5EF4-FFF2-40B4-BE49-F238E27FC236}">
                 <a16:creationId xmlns:a16="http://schemas.microsoft.com/office/drawing/2014/main" id="{E41E2BF3-686D-4C53-8537-FA2B67417072}"/>
               </a:ext>
             </a:extLst>
           </p:cNvPr>
           <p:cNvSpPr>
-            <a:spLocks xmlns:a="http://schemas.openxmlformats.org/drawingml/2006/main" noGrp="1"/>
+            <a:spLocks noGrp="1"/>
           </p:cNvSpPr>
           <p:nvPr/>
         </p:nvSpPr>
         <p:spPr>
-          <a:xfrm xmlns:a="http://schemas.openxmlformats.org/drawingml/2006/main">
+          <a:xfrm>
             <a:off x="609600" y="5353050"/>
             <a:ext cx="10953750" cy="409575"/>
           </a:xfrm>
-          <a:prstGeom xmlns:a="http://schemas.openxmlformats.org/drawingml/2006/main" prst="rect">
+          <a:prstGeom prst="rect">
             <a:avLst/>
           </a:prstGeom>
-          <a:noFill xmlns:a="http://schemas.openxmlformats.org/drawingml/2006/main"/>
-          <a:ln xmlns:a="http://schemas.openxmlformats.org/drawingml/2006/main" w="0">
+          <a:noFill/>
+          <a:ln w="0">
             <a:noFill/>
           </a:ln>
         </p:spPr>
         <p:txBody>
-          <a:bodyPr xmlns:a="http://schemas.openxmlformats.org/drawingml/2006/main"/>
-          <a:lstStyle xmlns:a="http://schemas.openxmlformats.org/drawingml/2006/main">
+          <a:bodyPr/>
+          <a:lstStyle>
             <a:defPPr>
               <a:defRPr sz="2400" b="1">
                 <a:solidFill>
@@ -7290,7 +7033,7 @@
               </a:defRPr>
             </a:lvl9pPr>
           </a:lstStyle>
-          <a:p xmlns:a="http://schemas.openxmlformats.org/drawingml/2006/main">
+          <a:p>
             <a:pPr>
               <a:defRPr sz="2400" b="1">
                 <a:solidFill>
@@ -7317,34 +7060,34 @@
       </p:sp>
       <p:sp>
         <p:nvSpPr>
-          <p:cNvPr id="14" name="">
-            <a:extLst xmlns:a="http://schemas.openxmlformats.org/drawingml/2006/main">
+          <p:cNvPr id="14" name="Rectangle 13">
+            <a:extLst>
               <a:ext uri="{FF2B5EF4-FFF2-40B4-BE49-F238E27FC236}">
                 <a16:creationId xmlns:a16="http://schemas.microsoft.com/office/drawing/2014/main" id="{25F98D42-4855-4386-A292-9092339A0D47}"/>
               </a:ext>
             </a:extLst>
           </p:cNvPr>
           <p:cNvSpPr>
-            <a:spLocks xmlns:a="http://schemas.openxmlformats.org/drawingml/2006/main" noGrp="1"/>
+            <a:spLocks noGrp="1"/>
           </p:cNvSpPr>
           <p:nvPr/>
         </p:nvSpPr>
         <p:spPr>
-          <a:xfrm xmlns:a="http://schemas.openxmlformats.org/drawingml/2006/main">
+          <a:xfrm>
             <a:off x="609600" y="5829300"/>
             <a:ext cx="10953750" cy="333375"/>
           </a:xfrm>
-          <a:prstGeom xmlns:a="http://schemas.openxmlformats.org/drawingml/2006/main" prst="rect">
+          <a:prstGeom prst="rect">
             <a:avLst/>
           </a:prstGeom>
-          <a:noFill xmlns:a="http://schemas.openxmlformats.org/drawingml/2006/main"/>
-          <a:ln xmlns:a="http://schemas.openxmlformats.org/drawingml/2006/main" w="0">
+          <a:noFill/>
+          <a:ln w="0">
             <a:noFill/>
           </a:ln>
         </p:spPr>
         <p:txBody>
-          <a:bodyPr xmlns:a="http://schemas.openxmlformats.org/drawingml/2006/main"/>
-          <a:lstStyle xmlns:a="http://schemas.openxmlformats.org/drawingml/2006/main">
+          <a:bodyPr/>
+          <a:lstStyle>
             <a:defPPr>
               <a:defRPr sz="1875" b="0">
                 <a:solidFill>
@@ -7446,7 +7189,7 @@
               </a:defRPr>
             </a:lvl9pPr>
           </a:lstStyle>
-          <a:p xmlns:a="http://schemas.openxmlformats.org/drawingml/2006/main">
+          <a:p>
             <a:pPr>
               <a:defRPr sz="1875" b="0">
                 <a:solidFill>
@@ -7478,17 +7221,21 @@
       </p:ext>
     </p:extLst>
   </p:cSld>
+  <p:clrMapOvr>
+    <a:masterClrMapping/>
+  </p:clrMapOvr>
 </p:sld>
 </file>
 
 <file path=ppt/slides/slide3.xml><?xml version="1.0" encoding="utf-8"?>
-<p:sld xmlns:p="http://schemas.openxmlformats.org/presentationml/2006/main">
+<p:sld xmlns:a="http://schemas.openxmlformats.org/drawingml/2006/main" xmlns:r="http://schemas.openxmlformats.org/officeDocument/2006/relationships" xmlns:p="http://schemas.openxmlformats.org/presentationml/2006/main">
   <p:cSld>
     <p:bg>
       <p:bgPr>
-        <a:solidFill xmlns:a="http://schemas.openxmlformats.org/drawingml/2006/main">
+        <a:solidFill>
           <a:srgbClr val="FFFFFF"/>
         </a:solidFill>
+        <a:effectLst/>
       </p:bgPr>
     </p:bg>
     <p:spTree>
@@ -7498,38 +7245,43 @@
         <p:nvPr/>
       </p:nvGrpSpPr>
       <p:grpSpPr>
-        <a:xfrm xmlns:a="http://schemas.openxmlformats.org/drawingml/2006/main"/>
+        <a:xfrm>
+          <a:off x="0" y="0"/>
+          <a:ext cx="0" cy="0"/>
+          <a:chOff x="0" y="0"/>
+          <a:chExt cx="0" cy="0"/>
+        </a:xfrm>
       </p:grpSpPr>
       <p:sp>
         <p:nvSpPr>
-          <p:cNvPr id="12" name="">
-            <a:extLst xmlns:a="http://schemas.openxmlformats.org/drawingml/2006/main">
+          <p:cNvPr id="12" name="Rectangle 11">
+            <a:extLst>
               <a:ext uri="{FF2B5EF4-FFF2-40B4-BE49-F238E27FC236}">
                 <a16:creationId xmlns:a16="http://schemas.microsoft.com/office/drawing/2014/main" id="{7A2B0001-63A9-4A4F-972A-A85114B9F730}"/>
               </a:ext>
             </a:extLst>
           </p:cNvPr>
           <p:cNvSpPr>
-            <a:spLocks xmlns:a="http://schemas.openxmlformats.org/drawingml/2006/main" noGrp="1"/>
+            <a:spLocks noGrp="1"/>
           </p:cNvSpPr>
           <p:nvPr/>
         </p:nvSpPr>
         <p:spPr>
-          <a:xfrm xmlns:a="http://schemas.openxmlformats.org/drawingml/2006/main">
+          <a:xfrm>
             <a:off x="609600" y="428625"/>
             <a:ext cx="10953750" cy="666750"/>
           </a:xfrm>
-          <a:prstGeom xmlns:a="http://schemas.openxmlformats.org/drawingml/2006/main" prst="rect">
+          <a:prstGeom prst="rect">
             <a:avLst/>
           </a:prstGeom>
-          <a:noFill xmlns:a="http://schemas.openxmlformats.org/drawingml/2006/main"/>
-          <a:ln xmlns:a="http://schemas.openxmlformats.org/drawingml/2006/main" w="0">
+          <a:noFill/>
+          <a:ln w="0">
             <a:noFill/>
           </a:ln>
         </p:spPr>
         <p:txBody>
-          <a:bodyPr xmlns:a="http://schemas.openxmlformats.org/drawingml/2006/main"/>
-          <a:lstStyle xmlns:a="http://schemas.openxmlformats.org/drawingml/2006/main">
+          <a:bodyPr/>
+          <a:lstStyle>
             <a:defPPr>
               <a:defRPr sz="3450" b="1">
                 <a:solidFill>
@@ -7631,7 +7383,7 @@
               </a:defRPr>
             </a:lvl9pPr>
           </a:lstStyle>
-          <a:p xmlns:a="http://schemas.openxmlformats.org/drawingml/2006/main">
+          <a:p>
             <a:pPr>
               <a:defRPr sz="3450" b="1">
                 <a:solidFill>
@@ -7658,34 +7410,34 @@
       </p:sp>
       <p:sp>
         <p:nvSpPr>
-          <p:cNvPr id="2" name="">
-            <a:extLst xmlns:a="http://schemas.openxmlformats.org/drawingml/2006/main">
+          <p:cNvPr id="2" name="Rectangle 1">
+            <a:extLst>
               <a:ext uri="{FF2B5EF4-FFF2-40B4-BE49-F238E27FC236}">
                 <a16:creationId xmlns:a16="http://schemas.microsoft.com/office/drawing/2014/main" id="{84E1A922-95CE-44CA-9574-9C860F04A532}"/>
               </a:ext>
             </a:extLst>
           </p:cNvPr>
           <p:cNvSpPr>
-            <a:spLocks xmlns:a="http://schemas.openxmlformats.org/drawingml/2006/main" noGrp="1"/>
+            <a:spLocks noGrp="1"/>
           </p:cNvSpPr>
           <p:nvPr/>
         </p:nvSpPr>
         <p:spPr>
-          <a:xfrm xmlns:a="http://schemas.openxmlformats.org/drawingml/2006/main">
+          <a:xfrm>
             <a:off x="609600" y="6400800"/>
             <a:ext cx="9525000" cy="238125"/>
           </a:xfrm>
-          <a:prstGeom xmlns:a="http://schemas.openxmlformats.org/drawingml/2006/main" prst="rect">
+          <a:prstGeom prst="rect">
             <a:avLst/>
           </a:prstGeom>
-          <a:noFill xmlns:a="http://schemas.openxmlformats.org/drawingml/2006/main"/>
-          <a:ln xmlns:a="http://schemas.openxmlformats.org/drawingml/2006/main" w="0">
+          <a:noFill/>
+          <a:ln w="0">
             <a:noFill/>
           </a:ln>
         </p:spPr>
         <p:txBody>
-          <a:bodyPr xmlns:a="http://schemas.openxmlformats.org/drawingml/2006/main"/>
-          <a:lstStyle xmlns:a="http://schemas.openxmlformats.org/drawingml/2006/main">
+          <a:bodyPr/>
+          <a:lstStyle>
             <a:defPPr>
               <a:defRPr sz="1275" b="0">
                 <a:solidFill>
@@ -7787,7 +7539,7 @@
               </a:defRPr>
             </a:lvl9pPr>
           </a:lstStyle>
-          <a:p xmlns:a="http://schemas.openxmlformats.org/drawingml/2006/main">
+          <a:p>
             <a:pPr>
               <a:defRPr sz="1275" b="0">
                 <a:solidFill>
@@ -7814,34 +7566,34 @@
       </p:sp>
       <p:sp>
         <p:nvSpPr>
-          <p:cNvPr id="3" name="">
-            <a:extLst xmlns:a="http://schemas.openxmlformats.org/drawingml/2006/main">
+          <p:cNvPr id="3" name="Rectangle 2">
+            <a:extLst>
               <a:ext uri="{FF2B5EF4-FFF2-40B4-BE49-F238E27FC236}">
                 <a16:creationId xmlns:a16="http://schemas.microsoft.com/office/drawing/2014/main" id="{0A12CAFA-DEAD-4A73-8442-FBB3F35BB0A2}"/>
               </a:ext>
             </a:extLst>
           </p:cNvPr>
           <p:cNvSpPr>
-            <a:spLocks xmlns:a="http://schemas.openxmlformats.org/drawingml/2006/main" noGrp="1"/>
+            <a:spLocks noGrp="1"/>
           </p:cNvSpPr>
           <p:nvPr/>
         </p:nvSpPr>
         <p:spPr>
-          <a:xfrm xmlns:a="http://schemas.openxmlformats.org/drawingml/2006/main">
+          <a:xfrm>
             <a:off x="11191875" y="6400800"/>
             <a:ext cx="428625" cy="238125"/>
           </a:xfrm>
-          <a:prstGeom xmlns:a="http://schemas.openxmlformats.org/drawingml/2006/main" prst="rect">
+          <a:prstGeom prst="rect">
             <a:avLst/>
           </a:prstGeom>
-          <a:noFill xmlns:a="http://schemas.openxmlformats.org/drawingml/2006/main"/>
-          <a:ln xmlns:a="http://schemas.openxmlformats.org/drawingml/2006/main" w="0">
+          <a:noFill/>
+          <a:ln w="0">
             <a:noFill/>
           </a:ln>
         </p:spPr>
         <p:txBody>
-          <a:bodyPr xmlns:a="http://schemas.openxmlformats.org/drawingml/2006/main"/>
-          <a:lstStyle xmlns:a="http://schemas.openxmlformats.org/drawingml/2006/main">
+          <a:bodyPr/>
+          <a:lstStyle>
             <a:defPPr>
               <a:defRPr sz="1275" b="0">
                 <a:solidFill>
@@ -7943,7 +7695,7 @@
               </a:defRPr>
             </a:lvl9pPr>
           </a:lstStyle>
-          <a:p xmlns:a="http://schemas.openxmlformats.org/drawingml/2006/main">
+          <a:p>
             <a:pPr>
               <a:defRPr sz="1275" b="0">
                 <a:solidFill>
@@ -7970,34 +7722,34 @@
       </p:sp>
       <p:sp>
         <p:nvSpPr>
-          <p:cNvPr id="4" name="">
-            <a:extLst xmlns:a="http://schemas.openxmlformats.org/drawingml/2006/main">
+          <p:cNvPr id="4" name="Rectangle 3">
+            <a:extLst>
               <a:ext uri="{FF2B5EF4-FFF2-40B4-BE49-F238E27FC236}">
                 <a16:creationId xmlns:a16="http://schemas.microsoft.com/office/drawing/2014/main" id="{4D49C72E-1FBE-4BAB-83FF-C11E5F2AE9FE}"/>
               </a:ext>
             </a:extLst>
           </p:cNvPr>
           <p:cNvSpPr>
-            <a:spLocks xmlns:a="http://schemas.openxmlformats.org/drawingml/2006/main" noGrp="1"/>
+            <a:spLocks noGrp="1"/>
           </p:cNvSpPr>
           <p:nvPr/>
         </p:nvSpPr>
         <p:spPr>
-          <a:xfrm xmlns:a="http://schemas.openxmlformats.org/drawingml/2006/main">
+          <a:xfrm>
             <a:off x="609600" y="1695450"/>
             <a:ext cx="10477500" cy="485775"/>
           </a:xfrm>
-          <a:prstGeom xmlns:a="http://schemas.openxmlformats.org/drawingml/2006/main" prst="rect">
+          <a:prstGeom prst="rect">
             <a:avLst/>
           </a:prstGeom>
-          <a:noFill xmlns:a="http://schemas.openxmlformats.org/drawingml/2006/main"/>
-          <a:ln xmlns:a="http://schemas.openxmlformats.org/drawingml/2006/main" w="0">
+          <a:noFill/>
+          <a:ln w="0">
             <a:noFill/>
           </a:ln>
         </p:spPr>
         <p:txBody>
-          <a:bodyPr xmlns:a="http://schemas.openxmlformats.org/drawingml/2006/main"/>
-          <a:lstStyle xmlns:a="http://schemas.openxmlformats.org/drawingml/2006/main">
+          <a:bodyPr/>
+          <a:lstStyle>
             <a:defPPr>
               <a:defRPr sz="2850" b="1">
                 <a:solidFill>
@@ -8099,7 +7851,7 @@
               </a:defRPr>
             </a:lvl9pPr>
           </a:lstStyle>
-          <a:p xmlns:a="http://schemas.openxmlformats.org/drawingml/2006/main">
+          <a:p>
             <a:pPr>
               <a:defRPr sz="2850" b="1">
                 <a:solidFill>
@@ -8126,34 +7878,34 @@
       </p:sp>
       <p:sp>
         <p:nvSpPr>
-          <p:cNvPr id="5" name="">
-            <a:extLst xmlns:a="http://schemas.openxmlformats.org/drawingml/2006/main">
+          <p:cNvPr id="5" name="Rectangle 4">
+            <a:extLst>
               <a:ext uri="{FF2B5EF4-FFF2-40B4-BE49-F238E27FC236}">
                 <a16:creationId xmlns:a16="http://schemas.microsoft.com/office/drawing/2014/main" id="{603CA1C3-65E6-47D8-BCAC-7584D3702026}"/>
               </a:ext>
             </a:extLst>
           </p:cNvPr>
           <p:cNvSpPr>
-            <a:spLocks xmlns:a="http://schemas.openxmlformats.org/drawingml/2006/main" noGrp="1"/>
+            <a:spLocks noGrp="1"/>
           </p:cNvSpPr>
           <p:nvPr/>
         </p:nvSpPr>
         <p:spPr>
-          <a:xfrm xmlns:a="http://schemas.openxmlformats.org/drawingml/2006/main">
+          <a:xfrm>
             <a:off x="609600" y="2190750"/>
             <a:ext cx="10477500" cy="409575"/>
           </a:xfrm>
-          <a:prstGeom xmlns:a="http://schemas.openxmlformats.org/drawingml/2006/main" prst="rect">
+          <a:prstGeom prst="rect">
             <a:avLst/>
           </a:prstGeom>
-          <a:noFill xmlns:a="http://schemas.openxmlformats.org/drawingml/2006/main"/>
-          <a:ln xmlns:a="http://schemas.openxmlformats.org/drawingml/2006/main" w="0">
+          <a:noFill/>
+          <a:ln w="0">
             <a:noFill/>
           </a:ln>
         </p:spPr>
         <p:txBody>
-          <a:bodyPr xmlns:a="http://schemas.openxmlformats.org/drawingml/2006/main"/>
-          <a:lstStyle xmlns:a="http://schemas.openxmlformats.org/drawingml/2006/main">
+          <a:bodyPr/>
+          <a:lstStyle>
             <a:defPPr>
               <a:defRPr sz="2325" b="0">
                 <a:solidFill>
@@ -8255,7 +8007,7 @@
               </a:defRPr>
             </a:lvl9pPr>
           </a:lstStyle>
-          <a:p xmlns:a="http://schemas.openxmlformats.org/drawingml/2006/main">
+          <a:p>
             <a:pPr>
               <a:defRPr sz="2325" b="0">
                 <a:solidFill>
@@ -8282,34 +8034,34 @@
       </p:sp>
       <p:sp>
         <p:nvSpPr>
-          <p:cNvPr id="6" name="">
-            <a:extLst xmlns:a="http://schemas.openxmlformats.org/drawingml/2006/main">
+          <p:cNvPr id="6" name="Rectangle 5">
+            <a:extLst>
               <a:ext uri="{FF2B5EF4-FFF2-40B4-BE49-F238E27FC236}">
                 <a16:creationId xmlns:a16="http://schemas.microsoft.com/office/drawing/2014/main" id="{60CF29EF-D630-473A-9F4D-1D32222020B2}"/>
               </a:ext>
             </a:extLst>
           </p:cNvPr>
           <p:cNvSpPr>
-            <a:spLocks xmlns:a="http://schemas.openxmlformats.org/drawingml/2006/main" noGrp="1"/>
+            <a:spLocks noGrp="1"/>
           </p:cNvSpPr>
           <p:nvPr/>
         </p:nvSpPr>
         <p:spPr>
-          <a:xfrm xmlns:a="http://schemas.openxmlformats.org/drawingml/2006/main">
+          <a:xfrm>
             <a:off x="609600" y="2714625"/>
             <a:ext cx="10477500" cy="342900"/>
           </a:xfrm>
-          <a:prstGeom xmlns:a="http://schemas.openxmlformats.org/drawingml/2006/main" prst="rect">
+          <a:prstGeom prst="rect">
             <a:avLst/>
           </a:prstGeom>
-          <a:noFill xmlns:a="http://schemas.openxmlformats.org/drawingml/2006/main"/>
-          <a:ln xmlns:a="http://schemas.openxmlformats.org/drawingml/2006/main" w="0">
+          <a:noFill/>
+          <a:ln w="0">
             <a:noFill/>
           </a:ln>
         </p:spPr>
         <p:txBody>
-          <a:bodyPr xmlns:a="http://schemas.openxmlformats.org/drawingml/2006/main"/>
-          <a:lstStyle xmlns:a="http://schemas.openxmlformats.org/drawingml/2006/main">
+          <a:bodyPr/>
+          <a:lstStyle>
             <a:defPPr>
               <a:defRPr sz="1950" b="0">
                 <a:solidFill>
@@ -8411,7 +8163,7 @@
               </a:defRPr>
             </a:lvl9pPr>
           </a:lstStyle>
-          <a:p xmlns:a="http://schemas.openxmlformats.org/drawingml/2006/main">
+          <a:p>
             <a:pPr>
               <a:defRPr sz="1950" b="0">
                 <a:solidFill>
@@ -8423,7 +8175,7 @@
               </a:defRPr>
             </a:pPr>
             <a:r>
-              <a:rPr sz="1950" b="0">
+              <a:rPr sz="1950" b="0" dirty="0">
                 <a:solidFill>
                   <a:srgbClr val="596773"/>
                 </a:solidFill>
@@ -8431,41 +8183,60 @@
                 <a:ea typeface="Arial"/>
                 <a:cs typeface="Arial"/>
               </a:rPr>
-              <a:t>Alfons Kemper und André Eickler</a:t>
+              <a:t>Alfons Kemper und André </a:t>
             </a:r>
+            <a:r>
+              <a:rPr sz="1950" b="0" dirty="0" err="1">
+                <a:solidFill>
+                  <a:srgbClr val="596773"/>
+                </a:solidFill>
+                <a:latin typeface="Arial"/>
+                <a:ea typeface="Arial"/>
+                <a:cs typeface="Arial"/>
+              </a:rPr>
+              <a:t>Eickler</a:t>
+            </a:r>
+            <a:endParaRPr sz="1950" b="0" dirty="0">
+              <a:solidFill>
+                <a:srgbClr val="596773"/>
+              </a:solidFill>
+              <a:latin typeface="Arial"/>
+              <a:ea typeface="Arial"/>
+              <a:cs typeface="Arial"/>
+            </a:endParaRPr>
           </a:p>
         </p:txBody>
       </p:sp>
       <p:sp>
         <p:nvSpPr>
-          <p:cNvPr id="7" name="">
-            <a:extLst xmlns:a="http://schemas.openxmlformats.org/drawingml/2006/main">
+          <p:cNvPr id="7" name="Rectangle 6">
+            <a:extLst>
               <a:ext uri="{FF2B5EF4-FFF2-40B4-BE49-F238E27FC236}">
                 <a16:creationId xmlns:a16="http://schemas.microsoft.com/office/drawing/2014/main" id="{BCDD0478-295D-4291-A628-BBE258D29320}"/>
               </a:ext>
             </a:extLst>
           </p:cNvPr>
           <p:cNvSpPr>
-            <a:spLocks xmlns:a="http://schemas.openxmlformats.org/drawingml/2006/main" noGrp="1"/>
+            <a:spLocks noGrp="1"/>
           </p:cNvSpPr>
           <p:nvPr/>
         </p:nvSpPr>
         <p:spPr>
-          <a:xfrm xmlns:a="http://schemas.openxmlformats.org/drawingml/2006/main">
+          <a:xfrm>
             <a:off x="609600" y="3152775"/>
             <a:ext cx="10477500" cy="361950"/>
           </a:xfrm>
-          <a:prstGeom xmlns:a="http://schemas.openxmlformats.org/drawingml/2006/main" prst="rect">
+          <a:prstGeom prst="rect">
             <a:avLst/>
           </a:prstGeom>
-          <a:noFill xmlns:a="http://schemas.openxmlformats.org/drawingml/2006/main"/>
-          <a:ln xmlns:a="http://schemas.openxmlformats.org/drawingml/2006/main" w="0">
+          <a:noFill/>
+          <a:ln w="0">
             <a:noFill/>
           </a:ln>
         </p:spPr>
         <p:txBody>
-          <a:bodyPr xmlns:a="http://schemas.openxmlformats.org/drawingml/2006/main"/>
-          <a:lstStyle xmlns:a="http://schemas.openxmlformats.org/drawingml/2006/main">
+          <a:bodyPr/>
+          <a:lstStyle>
             <a:defPPr>
               <a:defRPr sz="2100" b="0">
                 <a:solidFill>
@@ -8567,7 +8338,7 @@
               </a:defRPr>
             </a:lvl9pPr>
           </a:lstStyle>
-          <a:p xmlns:a="http://schemas.openxmlformats.org/drawingml/2006/main">
+          <a:p>
             <a:pPr>
               <a:defRPr sz="2100" b="0">
                 <a:solidFill>
@@ -8579,7 +8350,7 @@
               </a:defRPr>
             </a:pPr>
             <a:r>
-              <a:rPr sz="2100" b="0">
+              <a:rPr sz="2100" b="0" dirty="0">
                 <a:solidFill>
                   <a:srgbClr val="202B33"/>
                 </a:solidFill>
@@ -8587,41 +8358,104 @@
                 <a:ea typeface="Arial"/>
                 <a:cs typeface="Arial"/>
               </a:rPr>
-              <a:t>Zum Nachlesen und Vertiefen der Vorlesungsinhalte</a:t>
+              <a:t>Zum </a:t>
             </a:r>
+            <a:r>
+              <a:rPr sz="2100" b="0" dirty="0" err="1">
+                <a:solidFill>
+                  <a:srgbClr val="202B33"/>
+                </a:solidFill>
+                <a:latin typeface="Arial"/>
+                <a:ea typeface="Arial"/>
+                <a:cs typeface="Arial"/>
+              </a:rPr>
+              <a:t>Nachlesen</a:t>
+            </a:r>
+            <a:r>
+              <a:rPr sz="2100" b="0" dirty="0">
+                <a:solidFill>
+                  <a:srgbClr val="202B33"/>
+                </a:solidFill>
+                <a:latin typeface="Arial"/>
+                <a:ea typeface="Arial"/>
+                <a:cs typeface="Arial"/>
+              </a:rPr>
+              <a:t> und </a:t>
+            </a:r>
+            <a:r>
+              <a:rPr sz="2100" b="0" dirty="0" err="1">
+                <a:solidFill>
+                  <a:srgbClr val="202B33"/>
+                </a:solidFill>
+                <a:latin typeface="Arial"/>
+                <a:ea typeface="Arial"/>
+                <a:cs typeface="Arial"/>
+              </a:rPr>
+              <a:t>Vertiefen</a:t>
+            </a:r>
+            <a:r>
+              <a:rPr sz="2100" b="0" dirty="0">
+                <a:solidFill>
+                  <a:srgbClr val="202B33"/>
+                </a:solidFill>
+                <a:latin typeface="Arial"/>
+                <a:ea typeface="Arial"/>
+                <a:cs typeface="Arial"/>
+              </a:rPr>
+              <a:t> der </a:t>
+            </a:r>
+            <a:r>
+              <a:rPr sz="2100" b="0" dirty="0" err="1">
+                <a:solidFill>
+                  <a:srgbClr val="202B33"/>
+                </a:solidFill>
+                <a:latin typeface="Arial"/>
+                <a:ea typeface="Arial"/>
+                <a:cs typeface="Arial"/>
+              </a:rPr>
+              <a:t>Vorlesungsinhalte</a:t>
+            </a:r>
+            <a:endParaRPr sz="2100" b="0" dirty="0">
+              <a:solidFill>
+                <a:srgbClr val="202B33"/>
+              </a:solidFill>
+              <a:latin typeface="Arial"/>
+              <a:ea typeface="Arial"/>
+              <a:cs typeface="Arial"/>
+            </a:endParaRPr>
           </a:p>
         </p:txBody>
       </p:sp>
       <p:sp>
         <p:nvSpPr>
-          <p:cNvPr id="8" name="">
-            <a:extLst xmlns:a="http://schemas.openxmlformats.org/drawingml/2006/main">
+          <p:cNvPr id="8" name="Rectangle 7">
+            <a:extLst>
               <a:ext uri="{FF2B5EF4-FFF2-40B4-BE49-F238E27FC236}">
                 <a16:creationId xmlns:a16="http://schemas.microsoft.com/office/drawing/2014/main" id="{290FBBFB-A550-4529-A3A2-E7008F481888}"/>
               </a:ext>
             </a:extLst>
           </p:cNvPr>
           <p:cNvSpPr>
-            <a:spLocks xmlns:a="http://schemas.openxmlformats.org/drawingml/2006/main" noGrp="1"/>
+            <a:spLocks noGrp="1"/>
           </p:cNvSpPr>
           <p:nvPr/>
         </p:nvSpPr>
         <p:spPr>
-          <a:xfrm xmlns:a="http://schemas.openxmlformats.org/drawingml/2006/main">
+          <a:xfrm>
             <a:off x="609600" y="3933825"/>
             <a:ext cx="10477500" cy="485775"/>
           </a:xfrm>
-          <a:prstGeom xmlns:a="http://schemas.openxmlformats.org/drawingml/2006/main" prst="rect">
+          <a:prstGeom prst="rect">
             <a:avLst/>
           </a:prstGeom>
-          <a:noFill xmlns:a="http://schemas.openxmlformats.org/drawingml/2006/main"/>
-          <a:ln xmlns:a="http://schemas.openxmlformats.org/drawingml/2006/main" w="0">
+          <a:noFill/>
+          <a:ln w="0">
             <a:noFill/>
           </a:ln>
         </p:spPr>
         <p:txBody>
-          <a:bodyPr xmlns:a="http://schemas.openxmlformats.org/drawingml/2006/main"/>
-          <a:lstStyle xmlns:a="http://schemas.openxmlformats.org/drawingml/2006/main">
+          <a:bodyPr/>
+          <a:lstStyle>
             <a:defPPr>
               <a:defRPr sz="2850" b="1">
                 <a:solidFill>
@@ -8723,7 +8557,7 @@
               </a:defRPr>
             </a:lvl9pPr>
           </a:lstStyle>
-          <a:p xmlns:a="http://schemas.openxmlformats.org/drawingml/2006/main">
+          <a:p>
             <a:pPr>
               <a:defRPr sz="2850" b="1">
                 <a:solidFill>
@@ -8750,34 +8584,34 @@
       </p:sp>
       <p:sp>
         <p:nvSpPr>
-          <p:cNvPr id="9" name="">
-            <a:extLst xmlns:a="http://schemas.openxmlformats.org/drawingml/2006/main">
+          <p:cNvPr id="9" name="Rectangle 8">
+            <a:extLst>
               <a:ext uri="{FF2B5EF4-FFF2-40B4-BE49-F238E27FC236}">
                 <a16:creationId xmlns:a16="http://schemas.microsoft.com/office/drawing/2014/main" id="{AB1FF644-BB01-4501-988A-80DD9A2FA9FF}"/>
               </a:ext>
             </a:extLst>
           </p:cNvPr>
           <p:cNvSpPr>
-            <a:spLocks xmlns:a="http://schemas.openxmlformats.org/drawingml/2006/main" noGrp="1"/>
+            <a:spLocks noGrp="1"/>
           </p:cNvSpPr>
           <p:nvPr/>
         </p:nvSpPr>
         <p:spPr>
-          <a:xfrm xmlns:a="http://schemas.openxmlformats.org/drawingml/2006/main">
+          <a:xfrm>
             <a:off x="609600" y="4505325"/>
             <a:ext cx="10477500" cy="342900"/>
           </a:xfrm>
-          <a:prstGeom xmlns:a="http://schemas.openxmlformats.org/drawingml/2006/main" prst="rect">
+          <a:prstGeom prst="rect">
             <a:avLst/>
           </a:prstGeom>
-          <a:noFill xmlns:a="http://schemas.openxmlformats.org/drawingml/2006/main"/>
-          <a:ln xmlns:a="http://schemas.openxmlformats.org/drawingml/2006/main" w="0">
+          <a:noFill/>
+          <a:ln w="0">
             <a:noFill/>
           </a:ln>
         </p:spPr>
         <p:txBody>
-          <a:bodyPr xmlns:a="http://schemas.openxmlformats.org/drawingml/2006/main"/>
-          <a:lstStyle xmlns:a="http://schemas.openxmlformats.org/drawingml/2006/main">
+          <a:bodyPr/>
+          <a:lstStyle>
             <a:defPPr>
               <a:defRPr sz="1950" b="0">
                 <a:solidFill>
@@ -8879,7 +8713,7 @@
               </a:defRPr>
             </a:lvl9pPr>
           </a:lstStyle>
-          <a:p xmlns:a="http://schemas.openxmlformats.org/drawingml/2006/main">
+          <a:p>
             <a:pPr>
               <a:defRPr sz="1950" b="0">
                 <a:solidFill>
@@ -8906,34 +8740,34 @@
       </p:sp>
       <p:sp>
         <p:nvSpPr>
-          <p:cNvPr id="10" name="">
-            <a:extLst xmlns:a="http://schemas.openxmlformats.org/drawingml/2006/main">
+          <p:cNvPr id="10" name="Rectangle 9">
+            <a:extLst>
               <a:ext uri="{FF2B5EF4-FFF2-40B4-BE49-F238E27FC236}">
                 <a16:creationId xmlns:a16="http://schemas.microsoft.com/office/drawing/2014/main" id="{70D8BE6F-D8A6-4CB5-92AB-338A8618322C}"/>
               </a:ext>
             </a:extLst>
           </p:cNvPr>
           <p:cNvSpPr>
-            <a:spLocks xmlns:a="http://schemas.openxmlformats.org/drawingml/2006/main" noGrp="1"/>
+            <a:spLocks noGrp="1"/>
           </p:cNvSpPr>
           <p:nvPr/>
         </p:nvSpPr>
         <p:spPr>
-          <a:xfrm xmlns:a="http://schemas.openxmlformats.org/drawingml/2006/main">
+          <a:xfrm>
             <a:off x="609600" y="4943475"/>
             <a:ext cx="10477500" cy="361950"/>
           </a:xfrm>
-          <a:prstGeom xmlns:a="http://schemas.openxmlformats.org/drawingml/2006/main" prst="rect">
+          <a:prstGeom prst="rect">
             <a:avLst/>
           </a:prstGeom>
-          <a:noFill xmlns:a="http://schemas.openxmlformats.org/drawingml/2006/main"/>
-          <a:ln xmlns:a="http://schemas.openxmlformats.org/drawingml/2006/main" w="0">
+          <a:noFill/>
+          <a:ln w="0">
             <a:noFill/>
           </a:ln>
         </p:spPr>
         <p:txBody>
-          <a:bodyPr xmlns:a="http://schemas.openxmlformats.org/drawingml/2006/main"/>
-          <a:lstStyle xmlns:a="http://schemas.openxmlformats.org/drawingml/2006/main">
+          <a:bodyPr/>
+          <a:lstStyle>
             <a:defPPr>
               <a:defRPr sz="2100" b="0">
                 <a:solidFill>
@@ -9035,7 +8869,7 @@
               </a:defRPr>
             </a:lvl9pPr>
           </a:lstStyle>
-          <a:p xmlns:a="http://schemas.openxmlformats.org/drawingml/2006/main">
+          <a:p>
             <a:pPr>
               <a:defRPr sz="2100" b="0">
                 <a:solidFill>
@@ -9062,34 +8896,34 @@
       </p:sp>
       <p:sp>
         <p:nvSpPr>
-          <p:cNvPr id="11" name="">
-            <a:extLst xmlns:a="http://schemas.openxmlformats.org/drawingml/2006/main">
+          <p:cNvPr id="11" name="Rectangle 10">
+            <a:extLst>
               <a:ext uri="{FF2B5EF4-FFF2-40B4-BE49-F238E27FC236}">
                 <a16:creationId xmlns:a16="http://schemas.microsoft.com/office/drawing/2014/main" id="{697726A7-3E36-4940-9DE5-40142DAC19EA}"/>
               </a:ext>
             </a:extLst>
           </p:cNvPr>
           <p:cNvSpPr>
-            <a:spLocks xmlns:a="http://schemas.openxmlformats.org/drawingml/2006/main" noGrp="1"/>
+            <a:spLocks noGrp="1"/>
           </p:cNvSpPr>
           <p:nvPr/>
         </p:nvSpPr>
         <p:spPr>
-          <a:xfrm xmlns:a="http://schemas.openxmlformats.org/drawingml/2006/main">
+          <a:xfrm>
             <a:off x="609600" y="5753100"/>
             <a:ext cx="10953750" cy="419100"/>
           </a:xfrm>
-          <a:prstGeom xmlns:a="http://schemas.openxmlformats.org/drawingml/2006/main" prst="rect">
+          <a:prstGeom prst="rect">
             <a:avLst/>
           </a:prstGeom>
-          <a:noFill xmlns:a="http://schemas.openxmlformats.org/drawingml/2006/main"/>
-          <a:ln xmlns:a="http://schemas.openxmlformats.org/drawingml/2006/main" w="0">
+          <a:noFill/>
+          <a:ln w="0">
             <a:noFill/>
           </a:ln>
         </p:spPr>
         <p:txBody>
-          <a:bodyPr xmlns:a="http://schemas.openxmlformats.org/drawingml/2006/main"/>
-          <a:lstStyle xmlns:a="http://schemas.openxmlformats.org/drawingml/2006/main">
+          <a:bodyPr/>
+          <a:lstStyle>
             <a:defPPr>
               <a:defRPr sz="2250" b="1">
                 <a:solidFill>
@@ -9191,7 +9025,7 @@
               </a:defRPr>
             </a:lvl9pPr>
           </a:lstStyle>
-          <a:p xmlns:a="http://schemas.openxmlformats.org/drawingml/2006/main">
+          <a:p>
             <a:pPr>
               <a:defRPr sz="2250" b="1">
                 <a:solidFill>
@@ -9216,6 +9050,42 @@
           </a:p>
         </p:txBody>
       </p:sp>
+      <p:pic>
+        <p:nvPicPr>
+          <p:cNvPr id="13" name="Picture 12" descr="A blue and green diagram and a blue and green diagram&#10;&#10;Description automatically generated">
+            <a:extLst>
+              <a:ext uri="{FF2B5EF4-FFF2-40B4-BE49-F238E27FC236}">
+                <a16:creationId xmlns:a16="http://schemas.microsoft.com/office/drawing/2014/main" id="{33204655-8541-869C-6477-E52D0D85AB98}"/>
+              </a:ext>
+            </a:extLst>
+          </p:cNvPr>
+          <p:cNvPicPr>
+            <a:picLocks noChangeAspect="1"/>
+          </p:cNvPicPr>
+          <p:nvPr/>
+        </p:nvPicPr>
+        <p:blipFill>
+          <a:blip r:embed="rId3">
+            <a:extLst>
+              <a:ext uri="{28A0092B-C50C-407E-A947-70E740481C1C}">
+                <a14:useLocalDpi xmlns:a14="http://schemas.microsoft.com/office/drawing/2010/main" val="0"/>
+              </a:ext>
+            </a:extLst>
+          </a:blip>
+          <a:stretch>
+            <a:fillRect/>
+          </a:stretch>
+        </p:blipFill>
+        <p:spPr>
+          <a:xfrm>
+            <a:off x="7055223" y="1678806"/>
+            <a:ext cx="5136777" cy="3323135"/>
+          </a:xfrm>
+          <a:prstGeom prst="rect">
+            <a:avLst/>
+          </a:prstGeom>
+        </p:spPr>
+      </p:pic>
     </p:spTree>
     <p:extLst>
       <p:ext uri="{BB962C8B-B14F-4D97-AF65-F5344CB8AC3E}">
@@ -9223,6 +9093,9 @@
       </p:ext>
     </p:extLst>
   </p:cSld>
+  <p:clrMapOvr>
+    <a:masterClrMapping/>
+  </p:clrMapOvr>
 </p:sld>
 </file>
 
@@ -9468,5 +9341,254 @@
       </a:bgFillStyleLst>
     </a:fmtScheme>
   </a:themeElements>
+  <a:objectDefaults/>
+  <a:extraClrSchemeLst/>
+</a:theme>
+</file>
+
+<file path=ppt/theme/theme2.xml><?xml version="1.0" encoding="utf-8"?>
+<a:theme xmlns:a="http://schemas.openxmlformats.org/drawingml/2006/main" name="ChatGPT">
+  <a:themeElements>
+    <a:clrScheme name="ChatGPT">
+      <a:dk1>
+        <a:srgbClr val="000000"/>
+      </a:dk1>
+      <a:lt1>
+        <a:srgbClr val="FFFFFF"/>
+      </a:lt1>
+      <a:dk2>
+        <a:srgbClr val="0E2841"/>
+      </a:dk2>
+      <a:lt2>
+        <a:srgbClr val="E8E8E8"/>
+      </a:lt2>
+      <a:accent1>
+        <a:srgbClr val="156082"/>
+      </a:accent1>
+      <a:accent2>
+        <a:srgbClr val="E97132"/>
+      </a:accent2>
+      <a:accent3>
+        <a:srgbClr val="196B24"/>
+      </a:accent3>
+      <a:accent4>
+        <a:srgbClr val="0F9ED5"/>
+      </a:accent4>
+      <a:accent5>
+        <a:srgbClr val="A02B93"/>
+      </a:accent5>
+      <a:accent6>
+        <a:srgbClr val="4EA72E"/>
+      </a:accent6>
+      <a:hlink>
+        <a:srgbClr val="467886"/>
+      </a:hlink>
+      <a:folHlink>
+        <a:srgbClr val="96607D"/>
+      </a:folHlink>
+    </a:clrScheme>
+    <a:fontScheme name="">
+      <a:majorFont>
+        <a:latin typeface="Aptos"/>
+        <a:ea typeface=""/>
+        <a:cs typeface=""/>
+      </a:majorFont>
+      <a:minorFont>
+        <a:latin typeface="Aptos"/>
+        <a:ea typeface=""/>
+        <a:cs typeface=""/>
+      </a:minorFont>
+    </a:fontScheme>
+    <a:fmtScheme name="ChatGPT">
+      <a:fillStyleLst>
+        <a:solidFill>
+          <a:schemeClr val="phClr"/>
+        </a:solidFill>
+        <a:gradFill>
+          <a:gsLst>
+            <a:gs pos="0">
+              <a:schemeClr val="phClr">
+                <a:tint val="67000"/>
+                <a:lumMod val="110000"/>
+                <a:satMod val="105000"/>
+              </a:schemeClr>
+            </a:gs>
+            <a:gs pos="50000">
+              <a:schemeClr val="phClr">
+                <a:tint val="73000"/>
+                <a:lumMod val="105000"/>
+                <a:satMod val="103000"/>
+              </a:schemeClr>
+            </a:gs>
+            <a:gs pos="100000">
+              <a:schemeClr val="phClr">
+                <a:tint val="81000"/>
+                <a:lumMod val="105000"/>
+                <a:satMod val="109000"/>
+              </a:schemeClr>
+            </a:gs>
+          </a:gsLst>
+          <a:lin ang="5400000" scaled="0"/>
+        </a:gradFill>
+        <a:gradFill>
+          <a:gsLst>
+            <a:gs pos="0">
+              <a:schemeClr val="phClr">
+                <a:tint val="94000"/>
+                <a:lumMod val="102000"/>
+                <a:satMod val="103000"/>
+              </a:schemeClr>
+            </a:gs>
+            <a:gs pos="50000">
+              <a:schemeClr val="phClr">
+                <a:shade val="100000"/>
+                <a:lumMod val="100000"/>
+                <a:satMod val="110000"/>
+              </a:schemeClr>
+            </a:gs>
+            <a:gs pos="100000">
+              <a:schemeClr val="phClr">
+                <a:shade val="78000"/>
+                <a:lumMod val="99000"/>
+                <a:satMod val="120000"/>
+              </a:schemeClr>
+            </a:gs>
+          </a:gsLst>
+          <a:lin ang="5400000" scaled="0"/>
+        </a:gradFill>
+      </a:fillStyleLst>
+      <a:lnStyleLst>
+        <a:ln w="12700">
+          <a:solidFill>
+            <a:schemeClr val="phClr"/>
+          </a:solidFill>
+          <a:prstDash val="solid"/>
+        </a:ln>
+        <a:ln w="19050">
+          <a:solidFill>
+            <a:schemeClr val="phClr"/>
+          </a:solidFill>
+          <a:prstDash val="solid"/>
+        </a:ln>
+        <a:ln w="25400">
+          <a:solidFill>
+            <a:schemeClr val="phClr"/>
+          </a:solidFill>
+          <a:prstDash val="solid"/>
+        </a:ln>
+      </a:lnStyleLst>
+      <a:effectStyleLst>
+        <a:effectStyle>
+          <a:effectLst/>
+        </a:effectStyle>
+        <a:effectStyle>
+          <a:effectLst/>
+        </a:effectStyle>
+        <a:effectStyle>
+          <a:effectLst>
+            <a:outerShdw blurRad="57150" dist="19050" dir="5400000">
+              <a:srgbClr val="000000">
+                <a:alpha val="16000"/>
+              </a:srgbClr>
+            </a:outerShdw>
+          </a:effectLst>
+        </a:effectStyle>
+        <a:effectStyle>
+          <a:effectLst>
+            <a:outerShdw blurRad="19050" dist="9525" dir="5400000">
+              <a:srgbClr val="000000">
+                <a:alpha val="6000"/>
+              </a:srgbClr>
+            </a:outerShdw>
+          </a:effectLst>
+        </a:effectStyle>
+        <a:effectStyle>
+          <a:effectLst>
+            <a:outerShdw blurRad="28575" dist="9525" dir="5400000">
+              <a:srgbClr val="000000">
+                <a:alpha val="8000"/>
+              </a:srgbClr>
+            </a:outerShdw>
+          </a:effectLst>
+        </a:effectStyle>
+        <a:effectStyle>
+          <a:effectLst>
+            <a:outerShdw blurRad="57150" dist="19050" dir="5400000">
+              <a:srgbClr val="000000">
+                <a:alpha val="10000"/>
+              </a:srgbClr>
+            </a:outerShdw>
+          </a:effectLst>
+        </a:effectStyle>
+        <a:effectStyle>
+          <a:effectLst>
+            <a:outerShdw blurRad="114300" dist="38100" dir="5400000">
+              <a:srgbClr val="000000">
+                <a:alpha val="12000"/>
+              </a:srgbClr>
+            </a:outerShdw>
+          </a:effectLst>
+        </a:effectStyle>
+        <a:effectStyle>
+          <a:effectLst>
+            <a:outerShdw blurRad="171450" dist="57150" dir="5400000">
+              <a:srgbClr val="000000">
+                <a:alpha val="16000"/>
+              </a:srgbClr>
+            </a:outerShdw>
+          </a:effectLst>
+        </a:effectStyle>
+        <a:effectStyle>
+          <a:effectLst>
+            <a:outerShdw blurRad="266700" dist="95250" dir="5400000">
+              <a:srgbClr val="000000">
+                <a:alpha val="24000"/>
+              </a:srgbClr>
+            </a:outerShdw>
+          </a:effectLst>
+        </a:effectStyle>
+      </a:effectStyleLst>
+      <a:bgFillStyleLst>
+        <a:solidFill>
+          <a:schemeClr val="phClr"/>
+        </a:solidFill>
+        <a:solidFill>
+          <a:schemeClr val="phClr">
+            <a:tint val="95000"/>
+            <a:satMod val="170000"/>
+          </a:schemeClr>
+        </a:solidFill>
+        <a:gradFill>
+          <a:gsLst>
+            <a:gs pos="0">
+              <a:schemeClr val="phClr">
+                <a:tint val="93000"/>
+                <a:shade val="98000"/>
+                <a:lumMod val="102000"/>
+                <a:satMod val="150000"/>
+              </a:schemeClr>
+            </a:gs>
+            <a:gs pos="50000">
+              <a:schemeClr val="phClr">
+                <a:tint val="98000"/>
+                <a:shade val="90000"/>
+                <a:lumMod val="103000"/>
+                <a:satMod val="130000"/>
+              </a:schemeClr>
+            </a:gs>
+            <a:gs pos="100000">
+              <a:schemeClr val="phClr">
+                <a:shade val="63000"/>
+                <a:satMod val="120000"/>
+              </a:schemeClr>
+            </a:gs>
+          </a:gsLst>
+          <a:lin ang="5400000" scaled="0"/>
+        </a:gradFill>
+      </a:bgFillStyleLst>
+    </a:fmtScheme>
+  </a:themeElements>
+  <a:objectDefaults/>
+  <a:extraClrSchemeLst/>
 </a:theme>
 </file>
</xml_diff>